<commit_message>
Revise test slides 1 and 3 per review and updated five-workflow copy
Slide 1: workflow chips for the five-workflow taxonomy, larger card
labels, aligned key-findings figures, three-paragraph positioning.
Slide 3: representative offerings moved into the chart table, light
header row, arrows between KPI tiles, neutral chat-claim legend,
full-width key takeaway; methodology note moved off-slide.

Co-Authored-By: Claude Opus 5.5 <noreply@anthropic.com>
Claude-Session: https://claude.ai/code/session_0198bm9pfzRwgZQBqNvd56W8
</commit_message>
<xml_diff>
--- a/deck/test-slides-1-3.pptx
+++ b/deck/test-slides-1-3.pptx
@@ -108,12 +108,12 @@
   <p:extLst>
     <p:ext uri="{521415D9-36F7-43E2-AB2F-B90AF26B5E84}">
       <p14:sectionLst xmlns:p14="http://schemas.microsoft.com/office/powerpoint/2010/main">
-        <p14:section name="Executive summary" id="{d79acef3-e6ee-f20a-5c79-506f0b9e77e5}">
+        <p14:section name="Executive summary" id="{f117afb3-2c34-6b08-5552-f22066b20e0f}">
           <p14:sldIdLst>
             <p14:sldId id="256"/>
           </p14:sldIdLst>
         </p14:section>
-        <p14:section name="U.S. competitive landscape" id="{730b3676-5e9d-d0cf-ad9a-8b6a233e2ea3}">
+        <p14:section name="U.S. competitive landscape" id="{8fbeba38-bf27-d05c-e062-d5788216b804}">
           <p14:sldIdLst>
             <p14:sldId id="257"/>
           </p14:sldIdLst>
@@ -1668,8 +1668,8 @@
         </p:nvSpPr>
         <p:spPr>
           <a:xfrm>
-            <a:off x="548640" y="1572768"/>
-            <a:ext cx="11091672" cy="1078992"/>
+            <a:off x="548640" y="1536192"/>
+            <a:ext cx="11091672" cy="1371600"/>
           </a:xfrm>
           <a:prstGeom prst="rect">
             <a:avLst/>
@@ -1695,8 +1695,8 @@
         </p:nvSpPr>
         <p:spPr>
           <a:xfrm>
-            <a:off x="777240" y="1783080"/>
-            <a:ext cx="457200" cy="457200"/>
+            <a:off x="777240" y="1737360"/>
+            <a:ext cx="475488" cy="475488"/>
           </a:xfrm>
           <a:prstGeom prst="ellipse">
             <a:avLst/>
@@ -1723,8 +1723,8 @@
         </p:blipFill>
         <p:spPr>
           <a:xfrm>
-            <a:off x="877824" y="1883664"/>
-            <a:ext cx="256032" cy="256032"/>
+            <a:off x="881847" y="1841967"/>
+            <a:ext cx="266273" cy="266273"/>
           </a:xfrm>
           <a:prstGeom prst="rect">
             <a:avLst/>
@@ -1733,14 +1733,50 @@
       </p:pic>
       <p:sp>
         <p:nvSpPr>
-          <p:cNvPr id="7" name="label"/>
-          <p:cNvSpPr txBox="1"/>
-          <p:nvPr/>
-        </p:nvSpPr>
-        <p:spPr>
-          <a:xfrm>
-            <a:off x="1417320" y="1737360"/>
-            <a:ext cx="5486400" cy="201168"/>
+          <p:cNvPr id="7" name="card label"/>
+          <p:cNvSpPr txBox="1"/>
+          <p:nvPr/>
+        </p:nvSpPr>
+        <p:spPr>
+          <a:xfrm>
+            <a:off x="1417320" y="1719072"/>
+            <a:ext cx="5486400" cy="274320"/>
+          </a:xfrm>
+          <a:prstGeom prst="rect">
+            <a:avLst/>
+          </a:prstGeom>
+          <a:noFill/>
+          <a:ln/>
+        </p:spPr>
+        <p:txBody>
+          <a:bodyPr wrap="square" lIns="0" tIns="0" rIns="0" bIns="0" rtlCol="0" anchor="ctr"/>
+          <a:lstStyle/>
+          <a:p>
+            <a:pPr indent="0" marL="0">
+              <a:buNone/>
+            </a:pPr>
+            <a:r>
+              <a:rPr lang="en-US" sz="1300" b="1" spc="150" kern="0" dirty="0">
+                <a:solidFill>
+                  <a:schemeClr val="accent2"/>
+                </a:solidFill>
+              </a:rPr>
+              <a:t>OUTSIDE-IN RESEARCH LENS</a:t>
+            </a:r>
+            <a:endParaRPr lang="en-US" sz="1300" dirty="0"/>
+          </a:p>
+        </p:txBody>
+      </p:sp>
+      <p:sp>
+        <p:nvSpPr>
+          <p:cNvPr id="8" name="Text 5"/>
+          <p:cNvSpPr txBox="1"/>
+          <p:nvPr/>
+        </p:nvSpPr>
+        <p:spPr>
+          <a:xfrm>
+            <a:off x="1417320" y="2048256"/>
+            <a:ext cx="9966960" cy="201168"/>
           </a:xfrm>
           <a:prstGeom prst="rect">
             <a:avLst/>
@@ -1756,12 +1792,75 @@
               <a:buNone/>
             </a:pPr>
             <a:r>
-              <a:rPr lang="en-US" sz="1000" b="1" spc="100" kern="0" dirty="0">
-                <a:solidFill>
-                  <a:schemeClr val="accent2"/>
-                </a:solidFill>
-              </a:rPr>
-              <a:t>OUTSIDE-IN RESEARCH LENS</a:t>
+              <a:rPr lang="en-US" sz="1100" dirty="0">
+                <a:solidFill>
+                  <a:schemeClr val="tx1"/>
+                </a:solidFill>
+              </a:rPr>
+              <a:t>An assessment of publicly marketed conversational AI across five Optum Life Sciences decision workflows:</a:t>
+            </a:r>
+            <a:endParaRPr lang="en-US" sz="1100" dirty="0"/>
+          </a:p>
+        </p:txBody>
+      </p:sp>
+      <p:sp>
+        <p:nvSpPr>
+          <p:cNvPr id="9" name="workflow chip RWE"/>
+          <p:cNvSpPr/>
+          <p:nvPr/>
+        </p:nvSpPr>
+        <p:spPr>
+          <a:xfrm>
+            <a:off x="1417320" y="2304288"/>
+            <a:ext cx="506578" cy="292608"/>
+          </a:xfrm>
+          <a:prstGeom prst="roundRect">
+            <a:avLst>
+              <a:gd name="adj" fmla="val 50000"/>
+            </a:avLst>
+          </a:prstGeom>
+          <a:solidFill>
+            <a:schemeClr val="accent5"/>
+          </a:solidFill>
+          <a:ln w="9525">
+            <a:solidFill>
+              <a:schemeClr val="accent1"/>
+            </a:solidFill>
+            <a:prstDash val="solid"/>
+          </a:ln>
+        </p:spPr>
+      </p:sp>
+      <p:sp>
+        <p:nvSpPr>
+          <p:cNvPr id="10" name="Text 7"/>
+          <p:cNvSpPr txBox="1"/>
+          <p:nvPr/>
+        </p:nvSpPr>
+        <p:spPr>
+          <a:xfrm>
+            <a:off x="1417320" y="2304288"/>
+            <a:ext cx="506578" cy="292608"/>
+          </a:xfrm>
+          <a:prstGeom prst="rect">
+            <a:avLst/>
+          </a:prstGeom>
+          <a:noFill/>
+          <a:ln/>
+        </p:spPr>
+        <p:txBody>
+          <a:bodyPr wrap="square" lIns="0" tIns="0" rIns="0" bIns="0" rtlCol="0" anchor="ctr"/>
+          <a:lstStyle/>
+          <a:p>
+            <a:pPr algn="ctr" indent="0" marL="0">
+              <a:buNone/>
+            </a:pPr>
+            <a:r>
+              <a:rPr lang="en-US" sz="1000" b="1" dirty="0">
+                <a:solidFill>
+                  <a:schemeClr val="accent1"/>
+                </a:solidFill>
+              </a:rPr>
+              <a:t>RWE</a:t>
             </a:r>
             <a:endParaRPr lang="en-US" sz="1000" dirty="0"/>
           </a:p>
@@ -1769,14 +1868,302 @@
       </p:sp>
       <p:sp>
         <p:nvSpPr>
-          <p:cNvPr id="8" name="Text 5"/>
-          <p:cNvSpPr txBox="1"/>
-          <p:nvPr/>
-        </p:nvSpPr>
-        <p:spPr>
-          <a:xfrm>
-            <a:off x="1417320" y="1965960"/>
-            <a:ext cx="9966960" cy="594360"/>
+          <p:cNvPr id="11" name="workflow chip Commercial intelligence"/>
+          <p:cNvSpPr/>
+          <p:nvPr/>
+        </p:nvSpPr>
+        <p:spPr>
+          <a:xfrm>
+            <a:off x="2033626" y="2304288"/>
+            <a:ext cx="1933042" cy="292608"/>
+          </a:xfrm>
+          <a:prstGeom prst="roundRect">
+            <a:avLst>
+              <a:gd name="adj" fmla="val 50000"/>
+            </a:avLst>
+          </a:prstGeom>
+          <a:solidFill>
+            <a:schemeClr val="accent5"/>
+          </a:solidFill>
+          <a:ln w="9525">
+            <a:solidFill>
+              <a:schemeClr val="accent1"/>
+            </a:solidFill>
+            <a:prstDash val="solid"/>
+          </a:ln>
+        </p:spPr>
+      </p:sp>
+      <p:sp>
+        <p:nvSpPr>
+          <p:cNvPr id="12" name="Text 9"/>
+          <p:cNvSpPr txBox="1"/>
+          <p:nvPr/>
+        </p:nvSpPr>
+        <p:spPr>
+          <a:xfrm>
+            <a:off x="2033626" y="2304288"/>
+            <a:ext cx="1933042" cy="292608"/>
+          </a:xfrm>
+          <a:prstGeom prst="rect">
+            <a:avLst/>
+          </a:prstGeom>
+          <a:noFill/>
+          <a:ln/>
+        </p:spPr>
+        <p:txBody>
+          <a:bodyPr wrap="square" lIns="0" tIns="0" rIns="0" bIns="0" rtlCol="0" anchor="ctr"/>
+          <a:lstStyle/>
+          <a:p>
+            <a:pPr algn="ctr" indent="0" marL="0">
+              <a:buNone/>
+            </a:pPr>
+            <a:r>
+              <a:rPr lang="en-US" sz="1000" b="1" dirty="0">
+                <a:solidFill>
+                  <a:schemeClr val="accent1"/>
+                </a:solidFill>
+              </a:rPr>
+              <a:t>Commercial intelligence</a:t>
+            </a:r>
+            <a:endParaRPr lang="en-US" sz="1000" dirty="0"/>
+          </a:p>
+        </p:txBody>
+      </p:sp>
+      <p:sp>
+        <p:nvSpPr>
+          <p:cNvPr id="13" name="workflow chip Medical / regulatory research"/>
+          <p:cNvSpPr/>
+          <p:nvPr/>
+        </p:nvSpPr>
+        <p:spPr>
+          <a:xfrm>
+            <a:off x="4076395" y="2304288"/>
+            <a:ext cx="2360981" cy="292608"/>
+          </a:xfrm>
+          <a:prstGeom prst="roundRect">
+            <a:avLst>
+              <a:gd name="adj" fmla="val 50000"/>
+            </a:avLst>
+          </a:prstGeom>
+          <a:solidFill>
+            <a:schemeClr val="accent5"/>
+          </a:solidFill>
+          <a:ln w="9525">
+            <a:solidFill>
+              <a:schemeClr val="accent1"/>
+            </a:solidFill>
+            <a:prstDash val="solid"/>
+          </a:ln>
+        </p:spPr>
+      </p:sp>
+      <p:sp>
+        <p:nvSpPr>
+          <p:cNvPr id="14" name="Text 11"/>
+          <p:cNvSpPr txBox="1"/>
+          <p:nvPr/>
+        </p:nvSpPr>
+        <p:spPr>
+          <a:xfrm>
+            <a:off x="4076395" y="2304288"/>
+            <a:ext cx="2360981" cy="292608"/>
+          </a:xfrm>
+          <a:prstGeom prst="rect">
+            <a:avLst/>
+          </a:prstGeom>
+          <a:noFill/>
+          <a:ln/>
+        </p:spPr>
+        <p:txBody>
+          <a:bodyPr wrap="square" lIns="0" tIns="0" rIns="0" bIns="0" rtlCol="0" anchor="ctr"/>
+          <a:lstStyle/>
+          <a:p>
+            <a:pPr algn="ctr" indent="0" marL="0">
+              <a:buNone/>
+            </a:pPr>
+            <a:r>
+              <a:rPr lang="en-US" sz="1000" b="1" dirty="0">
+                <a:solidFill>
+                  <a:schemeClr val="accent1"/>
+                </a:solidFill>
+              </a:rPr>
+              <a:t>Medical / regulatory research</a:t>
+            </a:r>
+            <a:endParaRPr lang="en-US" sz="1000" dirty="0"/>
+          </a:p>
+        </p:txBody>
+      </p:sp>
+      <p:sp>
+        <p:nvSpPr>
+          <p:cNvPr id="15" name="workflow chip Clinical trials"/>
+          <p:cNvSpPr/>
+          <p:nvPr/>
+        </p:nvSpPr>
+        <p:spPr>
+          <a:xfrm>
+            <a:off x="6547104" y="2304288"/>
+            <a:ext cx="1362456" cy="292608"/>
+          </a:xfrm>
+          <a:prstGeom prst="roundRect">
+            <a:avLst>
+              <a:gd name="adj" fmla="val 50000"/>
+            </a:avLst>
+          </a:prstGeom>
+          <a:solidFill>
+            <a:schemeClr val="accent5"/>
+          </a:solidFill>
+          <a:ln w="9525">
+            <a:solidFill>
+              <a:schemeClr val="accent1"/>
+            </a:solidFill>
+            <a:prstDash val="solid"/>
+          </a:ln>
+        </p:spPr>
+      </p:sp>
+      <p:sp>
+        <p:nvSpPr>
+          <p:cNvPr id="16" name="Text 13"/>
+          <p:cNvSpPr txBox="1"/>
+          <p:nvPr/>
+        </p:nvSpPr>
+        <p:spPr>
+          <a:xfrm>
+            <a:off x="6547104" y="2304288"/>
+            <a:ext cx="1362456" cy="292608"/>
+          </a:xfrm>
+          <a:prstGeom prst="rect">
+            <a:avLst/>
+          </a:prstGeom>
+          <a:noFill/>
+          <a:ln/>
+        </p:spPr>
+        <p:txBody>
+          <a:bodyPr wrap="square" lIns="0" tIns="0" rIns="0" bIns="0" rtlCol="0" anchor="ctr"/>
+          <a:lstStyle/>
+          <a:p>
+            <a:pPr algn="ctr" indent="0" marL="0">
+              <a:buNone/>
+            </a:pPr>
+            <a:r>
+              <a:rPr lang="en-US" sz="1000" b="1" dirty="0">
+                <a:solidFill>
+                  <a:schemeClr val="accent1"/>
+                </a:solidFill>
+              </a:rPr>
+              <a:t>Clinical trials</a:t>
+            </a:r>
+            <a:endParaRPr lang="en-US" sz="1000" dirty="0"/>
+          </a:p>
+        </p:txBody>
+      </p:sp>
+      <p:sp>
+        <p:nvSpPr>
+          <p:cNvPr id="17" name="Text 14"/>
+          <p:cNvSpPr txBox="1"/>
+          <p:nvPr/>
+        </p:nvSpPr>
+        <p:spPr>
+          <a:xfrm>
+            <a:off x="8019288" y="2304288"/>
+            <a:ext cx="329184" cy="292608"/>
+          </a:xfrm>
+          <a:prstGeom prst="rect">
+            <a:avLst/>
+          </a:prstGeom>
+          <a:noFill/>
+          <a:ln/>
+        </p:spPr>
+        <p:txBody>
+          <a:bodyPr wrap="square" lIns="0" tIns="0" rIns="0" bIns="0" rtlCol="0" anchor="ctr"/>
+          <a:lstStyle/>
+          <a:p>
+            <a:pPr algn="ctr" indent="0" marL="0">
+              <a:buNone/>
+            </a:pPr>
+            <a:r>
+              <a:rPr lang="en-US" sz="1000" dirty="0">
+                <a:solidFill>
+                  <a:schemeClr val="accent4"/>
+                </a:solidFill>
+              </a:rPr>
+              <a:t>and</a:t>
+            </a:r>
+            <a:endParaRPr lang="en-US" sz="1000" dirty="0"/>
+          </a:p>
+        </p:txBody>
+      </p:sp>
+      <p:sp>
+        <p:nvSpPr>
+          <p:cNvPr id="18" name="workflow chip Market access"/>
+          <p:cNvSpPr/>
+          <p:nvPr/>
+        </p:nvSpPr>
+        <p:spPr>
+          <a:xfrm>
+            <a:off x="8403336" y="2304288"/>
+            <a:ext cx="1219810" cy="292608"/>
+          </a:xfrm>
+          <a:prstGeom prst="roundRect">
+            <a:avLst>
+              <a:gd name="adj" fmla="val 50000"/>
+            </a:avLst>
+          </a:prstGeom>
+          <a:solidFill>
+            <a:schemeClr val="accent5"/>
+          </a:solidFill>
+          <a:ln w="9525">
+            <a:solidFill>
+              <a:schemeClr val="accent1"/>
+            </a:solidFill>
+            <a:prstDash val="solid"/>
+          </a:ln>
+        </p:spPr>
+      </p:sp>
+      <p:sp>
+        <p:nvSpPr>
+          <p:cNvPr id="19" name="Text 16"/>
+          <p:cNvSpPr txBox="1"/>
+          <p:nvPr/>
+        </p:nvSpPr>
+        <p:spPr>
+          <a:xfrm>
+            <a:off x="8403336" y="2304288"/>
+            <a:ext cx="1219810" cy="292608"/>
+          </a:xfrm>
+          <a:prstGeom prst="rect">
+            <a:avLst/>
+          </a:prstGeom>
+          <a:noFill/>
+          <a:ln/>
+        </p:spPr>
+        <p:txBody>
+          <a:bodyPr wrap="square" lIns="0" tIns="0" rIns="0" bIns="0" rtlCol="0" anchor="ctr"/>
+          <a:lstStyle/>
+          <a:p>
+            <a:pPr algn="ctr" indent="0" marL="0">
+              <a:buNone/>
+            </a:pPr>
+            <a:r>
+              <a:rPr lang="en-US" sz="1000" b="1" dirty="0">
+                <a:solidFill>
+                  <a:schemeClr val="accent1"/>
+                </a:solidFill>
+              </a:rPr>
+              <a:t>Market access</a:t>
+            </a:r>
+            <a:endParaRPr lang="en-US" sz="1000" dirty="0"/>
+          </a:p>
+        </p:txBody>
+      </p:sp>
+      <p:sp>
+        <p:nvSpPr>
+          <p:cNvPr id="20" name="Text 17"/>
+          <p:cNvSpPr txBox="1"/>
+          <p:nvPr/>
+        </p:nvSpPr>
+        <p:spPr>
+          <a:xfrm>
+            <a:off x="1417320" y="2651760"/>
+            <a:ext cx="9966960" cy="201168"/>
           </a:xfrm>
           <a:prstGeom prst="rect">
             <a:avLst/>
@@ -1789,9 +2176,6 @@
           <a:lstStyle/>
           <a:p>
             <a:pPr indent="0" marL="0">
-              <a:spcAft>
-                <a:spcPts val="300"/>
-              </a:spcAft>
               <a:buNone/>
             </a:pPr>
             <a:r>
@@ -1800,39 +2184,22 @@
                   <a:schemeClr val="tx1"/>
                 </a:solidFill>
               </a:rPr>
-              <a:t>An assessment of publicly-marketed conversational AI products across six core Optum Life Sciences workflows: data access, RWE, market access, clinical trials, commercial intelligence, and medical/regulatory research.</a:t>
+              <a:t>The U.S. competitive landscape is the primary focus; selected international offerings provide context; and Optum LS is the strategic reference point.</a:t>
             </a:r>
             <a:endParaRPr lang="en-US" sz="1100" dirty="0"/>
           </a:p>
-          <a:p>
-            <a:pPr indent="0" marL="0">
-              <a:spcAft>
-                <a:spcPts val="300"/>
-              </a:spcAft>
-              <a:buNone/>
-            </a:pPr>
-            <a:r>
-              <a:rPr lang="en-US" sz="1100" dirty="0">
-                <a:solidFill>
-                  <a:schemeClr val="tx1"/>
-                </a:solidFill>
-              </a:rPr>
-              <a:t>The U.S. competitive landscape is the primary focus; selected international offerings provide context; and Optum LS is the strategic reference point.</a:t>
-            </a:r>
-            <a:endParaRPr lang="en-US" sz="1100" dirty="0"/>
-          </a:p>
-        </p:txBody>
-      </p:sp>
-      <p:sp>
-        <p:nvSpPr>
-          <p:cNvPr id="9" name="key findings card"/>
+        </p:txBody>
+      </p:sp>
+      <p:sp>
+        <p:nvSpPr>
+          <p:cNvPr id="21" name="key findings card"/>
           <p:cNvSpPr/>
           <p:nvPr/>
         </p:nvSpPr>
         <p:spPr>
           <a:xfrm>
-            <a:off x="548640" y="2788920"/>
-            <a:ext cx="3575304" cy="2816352"/>
+            <a:off x="548640" y="3035808"/>
+            <a:ext cx="3575304" cy="2606040"/>
           </a:xfrm>
           <a:prstGeom prst="rect">
             <a:avLst/>
@@ -1852,14 +2219,14 @@
       </p:sp>
       <p:sp>
         <p:nvSpPr>
-          <p:cNvPr id="10" name="icon circle"/>
+          <p:cNvPr id="22" name="icon circle"/>
           <p:cNvSpPr/>
           <p:nvPr/>
         </p:nvSpPr>
         <p:spPr>
           <a:xfrm>
-            <a:off x="777240" y="3017520"/>
-            <a:ext cx="420624" cy="420624"/>
+            <a:off x="777240" y="3236976"/>
+            <a:ext cx="457200" cy="457200"/>
           </a:xfrm>
           <a:prstGeom prst="ellipse">
             <a:avLst/>
@@ -1872,7 +2239,7 @@
       </p:sp>
       <p:pic>
         <p:nvPicPr>
-          <p:cNvPr id="11" name="icon MdInsights" descr="preencoded.png">    </p:cNvPr>
+          <p:cNvPr id="23" name="icon MdInsights" descr="preencoded.png">    </p:cNvPr>
           <p:cNvPicPr>
             <a:picLocks noChangeAspect="1"/>
           </p:cNvPicPr>
@@ -1886,8 +2253,8 @@
         </p:blipFill>
         <p:spPr>
           <a:xfrm>
-            <a:off x="869777" y="3110057"/>
-            <a:ext cx="235549" cy="235549"/>
+            <a:off x="877824" y="3337560"/>
+            <a:ext cx="256032" cy="256032"/>
           </a:xfrm>
           <a:prstGeom prst="rect">
             <a:avLst/>
@@ -1896,14 +2263,50 @@
       </p:pic>
       <p:sp>
         <p:nvSpPr>
-          <p:cNvPr id="12" name="label"/>
-          <p:cNvSpPr txBox="1"/>
-          <p:nvPr/>
-        </p:nvSpPr>
-        <p:spPr>
-          <a:xfrm>
-            <a:off x="1325880" y="3127248"/>
-            <a:ext cx="2560320" cy="201168"/>
+          <p:cNvPr id="24" name="card label"/>
+          <p:cNvSpPr txBox="1"/>
+          <p:nvPr/>
+        </p:nvSpPr>
+        <p:spPr>
+          <a:xfrm>
+            <a:off x="1353312" y="3328416"/>
+            <a:ext cx="2660904" cy="274320"/>
+          </a:xfrm>
+          <a:prstGeom prst="rect">
+            <a:avLst/>
+          </a:prstGeom>
+          <a:noFill/>
+          <a:ln/>
+        </p:spPr>
+        <p:txBody>
+          <a:bodyPr wrap="square" lIns="0" tIns="0" rIns="0" bIns="0" rtlCol="0" anchor="ctr"/>
+          <a:lstStyle/>
+          <a:p>
+            <a:pPr indent="0" marL="0">
+              <a:buNone/>
+            </a:pPr>
+            <a:r>
+              <a:rPr lang="en-US" sz="1300" b="1" spc="150" kern="0" dirty="0">
+                <a:solidFill>
+                  <a:schemeClr val="accent2"/>
+                </a:solidFill>
+              </a:rPr>
+              <a:t>KEY FINDINGS</a:t>
+            </a:r>
+            <a:endParaRPr lang="en-US" sz="1300" dirty="0"/>
+          </a:p>
+        </p:txBody>
+      </p:sp>
+      <p:sp>
+        <p:nvSpPr>
+          <p:cNvPr id="25" name="hero 19"/>
+          <p:cNvSpPr txBox="1"/>
+          <p:nvPr/>
+        </p:nvSpPr>
+        <p:spPr>
+          <a:xfrm>
+            <a:off x="777240" y="3840480"/>
+            <a:ext cx="621792" cy="502920"/>
           </a:xfrm>
           <a:prstGeom prst="rect">
             <a:avLst/>
@@ -1919,27 +2322,27 @@
               <a:buNone/>
             </a:pPr>
             <a:r>
-              <a:rPr lang="en-US" sz="1000" b="1" spc="100" kern="0" dirty="0">
+              <a:rPr lang="en-US" sz="3400" b="1" dirty="0">
                 <a:solidFill>
                   <a:schemeClr val="accent2"/>
                 </a:solidFill>
               </a:rPr>
-              <a:t>KEY FINDINGS</a:t>
-            </a:r>
-            <a:endParaRPr lang="en-US" sz="1000" dirty="0"/>
-          </a:p>
-        </p:txBody>
-      </p:sp>
-      <p:sp>
-        <p:nvSpPr>
-          <p:cNvPr id="13" name="hero 19"/>
-          <p:cNvSpPr txBox="1"/>
-          <p:nvPr/>
-        </p:nvSpPr>
-        <p:spPr>
-          <a:xfrm>
-            <a:off x="777240" y="3575304"/>
-            <a:ext cx="777240" cy="548640"/>
+              <a:t>19</a:t>
+            </a:r>
+            <a:endParaRPr lang="en-US" sz="3400" dirty="0"/>
+          </a:p>
+        </p:txBody>
+      </p:sp>
+      <p:sp>
+        <p:nvSpPr>
+          <p:cNvPr id="26" name="Text 22"/>
+          <p:cNvSpPr txBox="1"/>
+          <p:nvPr/>
+        </p:nvSpPr>
+        <p:spPr>
+          <a:xfrm>
+            <a:off x="1444752" y="3904488"/>
+            <a:ext cx="2478024" cy="749808"/>
           </a:xfrm>
           <a:prstGeom prst="rect">
             <a:avLst/>
@@ -1955,70 +2358,12 @@
               <a:buNone/>
             </a:pPr>
             <a:r>
-              <a:rPr lang="en-US" sz="3600" b="1" dirty="0">
-                <a:solidFill>
-                  <a:schemeClr val="accent2"/>
-                </a:solidFill>
-              </a:rPr>
-              <a:t>19</a:t>
-            </a:r>
-            <a:endParaRPr lang="en-US" sz="3600" dirty="0"/>
-          </a:p>
-        </p:txBody>
-      </p:sp>
-      <p:sp>
-        <p:nvSpPr>
-          <p:cNvPr id="14" name="Text 10"/>
-          <p:cNvSpPr txBox="1"/>
-          <p:nvPr/>
-        </p:nvSpPr>
-        <p:spPr>
-          <a:xfrm>
-            <a:off x="1572768" y="3611880"/>
-            <a:ext cx="2359152" cy="896112"/>
-          </a:xfrm>
-          <a:prstGeom prst="rect">
-            <a:avLst/>
-          </a:prstGeom>
-          <a:noFill/>
-          <a:ln/>
-        </p:spPr>
-        <p:txBody>
-          <a:bodyPr wrap="square" lIns="0" tIns="0" rIns="0" bIns="0" rtlCol="0" anchor="t"/>
-          <a:lstStyle/>
-          <a:p>
-            <a:pPr indent="0" marL="0">
-              <a:buNone/>
-            </a:pPr>
-            <a:r>
               <a:rPr lang="en-US" sz="1050" dirty="0">
                 <a:solidFill>
                   <a:schemeClr val="tx1"/>
                 </a:solidFill>
               </a:rPr>
-              <a:t>The U.S. screen identified </a:t>
-            </a:r>
-            <a:pPr indent="0" marL="0">
-              <a:buNone/>
-            </a:pPr>
-            <a:r>
-              <a:rPr lang="en-US" sz="1050" b="1" dirty="0">
-                <a:solidFill>
-                  <a:schemeClr val="tx1"/>
-                </a:solidFill>
-              </a:rPr>
-              <a:t>19 qualifying conversational AI offerings across five of six domains</a:t>
-            </a:r>
-            <a:pPr indent="0" marL="0">
-              <a:buNone/>
-            </a:pPr>
-            <a:r>
-              <a:rPr lang="en-US" sz="1050" dirty="0">
-                <a:solidFill>
-                  <a:schemeClr val="tx1"/>
-                </a:solidFill>
-              </a:rPr>
-              <a:t>, concentrated in RWE and commercial intelligence.</a:t>
+              <a:t>The U.S. screen identified 19 qualifying conversational AI offerings across five decision workflows, concentrated in RWE and commercial intelligence.</a:t>
             </a:r>
             <a:endParaRPr lang="en-US" sz="1050" dirty="0"/>
           </a:p>
@@ -2026,13 +2371,13 @@
       </p:sp>
       <p:sp>
         <p:nvSpPr>
-          <p:cNvPr id="15" name="Shape 11"/>
+          <p:cNvPr id="27" name="Shape 23"/>
           <p:cNvSpPr/>
           <p:nvPr/>
         </p:nvSpPr>
         <p:spPr>
           <a:xfrm>
-            <a:off x="777240" y="4590288"/>
+            <a:off x="777240" y="4690872"/>
             <a:ext cx="3118104" cy="0"/>
           </a:xfrm>
           <a:prstGeom prst="line">
@@ -2049,14 +2394,14 @@
       </p:sp>
       <p:sp>
         <p:nvSpPr>
-          <p:cNvPr id="16" name="hero 10"/>
-          <p:cNvSpPr txBox="1"/>
-          <p:nvPr/>
-        </p:nvSpPr>
-        <p:spPr>
-          <a:xfrm>
-            <a:off x="777240" y="4663440"/>
-            <a:ext cx="777240" cy="548640"/>
+          <p:cNvPr id="28" name="hero 10"/>
+          <p:cNvSpPr txBox="1"/>
+          <p:nvPr/>
+        </p:nvSpPr>
+        <p:spPr>
+          <a:xfrm>
+            <a:off x="777240" y="4736592"/>
+            <a:ext cx="621792" cy="502920"/>
           </a:xfrm>
           <a:prstGeom prst="rect">
             <a:avLst/>
@@ -2072,27 +2417,27 @@
               <a:buNone/>
             </a:pPr>
             <a:r>
-              <a:rPr lang="en-US" sz="3600" b="1" dirty="0">
+              <a:rPr lang="en-US" sz="3400" b="1" dirty="0">
                 <a:solidFill>
                   <a:schemeClr val="accent2"/>
                 </a:solidFill>
               </a:rPr>
               <a:t>10</a:t>
             </a:r>
-            <a:endParaRPr lang="en-US" sz="3600" dirty="0"/>
-          </a:p>
-        </p:txBody>
-      </p:sp>
-      <p:sp>
-        <p:nvSpPr>
-          <p:cNvPr id="17" name="Text 13"/>
-          <p:cNvSpPr txBox="1"/>
-          <p:nvPr/>
-        </p:nvSpPr>
-        <p:spPr>
-          <a:xfrm>
-            <a:off x="1572768" y="4700016"/>
-            <a:ext cx="2359152" cy="822960"/>
+            <a:endParaRPr lang="en-US" sz="3400" dirty="0"/>
+          </a:p>
+        </p:txBody>
+      </p:sp>
+      <p:sp>
+        <p:nvSpPr>
+          <p:cNvPr id="29" name="Text 25"/>
+          <p:cNvSpPr txBox="1"/>
+          <p:nvPr/>
+        </p:nvSpPr>
+        <p:spPr>
+          <a:xfrm>
+            <a:off x="1444752" y="4800600"/>
+            <a:ext cx="2478024" cy="749808"/>
           </a:xfrm>
           <a:prstGeom prst="rect">
             <a:avLst/>
@@ -2113,29 +2458,7 @@
                   <a:schemeClr val="tx1"/>
                 </a:solidFill>
               </a:rPr>
-              <a:t>The selected international comparison identified </a:t>
-            </a:r>
-            <a:pPr indent="0" marL="0">
-              <a:buNone/>
-            </a:pPr>
-            <a:r>
-              <a:rPr lang="en-US" sz="1050" b="1" dirty="0">
-                <a:solidFill>
-                  <a:schemeClr val="tx1"/>
-                </a:solidFill>
-              </a:rPr>
-              <a:t>10 qualifying offerings</a:t>
-            </a:r>
-            <a:pPr indent="0" marL="0">
-              <a:buNone/>
-            </a:pPr>
-            <a:r>
-              <a:rPr lang="en-US" sz="1050" dirty="0">
-                <a:solidFill>
-                  <a:schemeClr val="tx1"/>
-                </a:solidFill>
-              </a:rPr>
-              <a:t>, providing additional examples of how vendors position conversational interaction.</a:t>
+              <a:t>The selected international comparison identified 10 qualifying offerings, providing additional examples of how vendors position conversational interaction.</a:t>
             </a:r>
             <a:endParaRPr lang="en-US" sz="1050" dirty="0"/>
           </a:p>
@@ -2143,14 +2466,14 @@
       </p:sp>
       <p:sp>
         <p:nvSpPr>
-          <p:cNvPr id="18" name="optum positioning card"/>
+          <p:cNvPr id="30" name="optum positioning card"/>
           <p:cNvSpPr/>
           <p:nvPr/>
         </p:nvSpPr>
         <p:spPr>
           <a:xfrm>
-            <a:off x="4306824" y="2788920"/>
-            <a:ext cx="3575304" cy="2816352"/>
+            <a:off x="4306824" y="3035808"/>
+            <a:ext cx="3575304" cy="2606040"/>
           </a:xfrm>
           <a:prstGeom prst="rect">
             <a:avLst/>
@@ -2170,14 +2493,14 @@
       </p:sp>
       <p:sp>
         <p:nvSpPr>
-          <p:cNvPr id="19" name="icon circle"/>
+          <p:cNvPr id="31" name="icon circle"/>
           <p:cNvSpPr/>
           <p:nvPr/>
         </p:nvSpPr>
         <p:spPr>
           <a:xfrm>
-            <a:off x="4535424" y="3017520"/>
-            <a:ext cx="420624" cy="420624"/>
+            <a:off x="4535424" y="3236976"/>
+            <a:ext cx="457200" cy="457200"/>
           </a:xfrm>
           <a:prstGeom prst="ellipse">
             <a:avLst/>
@@ -2190,7 +2513,7 @@
       </p:sp>
       <p:pic>
         <p:nvPicPr>
-          <p:cNvPr id="20" name="icon MdOutlineLayers" descr="preencoded.png">    </p:cNvPr>
+          <p:cNvPr id="32" name="icon MdOutlineLayers" descr="preencoded.png">    </p:cNvPr>
           <p:cNvPicPr>
             <a:picLocks noChangeAspect="1"/>
           </p:cNvPicPr>
@@ -2204,8 +2527,8 @@
         </p:blipFill>
         <p:spPr>
           <a:xfrm>
-            <a:off x="4627961" y="3110057"/>
-            <a:ext cx="235549" cy="235549"/>
+            <a:off x="4636008" y="3337560"/>
+            <a:ext cx="256032" cy="256032"/>
           </a:xfrm>
           <a:prstGeom prst="rect">
             <a:avLst/>
@@ -2214,14 +2537,50 @@
       </p:pic>
       <p:sp>
         <p:nvSpPr>
-          <p:cNvPr id="21" name="label"/>
-          <p:cNvSpPr txBox="1"/>
-          <p:nvPr/>
-        </p:nvSpPr>
-        <p:spPr>
-          <a:xfrm>
-            <a:off x="5084064" y="3127248"/>
-            <a:ext cx="2560320" cy="201168"/>
+          <p:cNvPr id="33" name="card label"/>
+          <p:cNvSpPr txBox="1"/>
+          <p:nvPr/>
+        </p:nvSpPr>
+        <p:spPr>
+          <a:xfrm>
+            <a:off x="5111496" y="3328416"/>
+            <a:ext cx="2660904" cy="274320"/>
+          </a:xfrm>
+          <a:prstGeom prst="rect">
+            <a:avLst/>
+          </a:prstGeom>
+          <a:noFill/>
+          <a:ln/>
+        </p:spPr>
+        <p:txBody>
+          <a:bodyPr wrap="square" lIns="0" tIns="0" rIns="0" bIns="0" rtlCol="0" anchor="ctr"/>
+          <a:lstStyle/>
+          <a:p>
+            <a:pPr indent="0" marL="0">
+              <a:buNone/>
+            </a:pPr>
+            <a:r>
+              <a:rPr lang="en-US" sz="1300" b="1" spc="150" kern="0" dirty="0">
+                <a:solidFill>
+                  <a:schemeClr val="accent2"/>
+                </a:solidFill>
+              </a:rPr>
+              <a:t>OPTUM POSITIONING</a:t>
+            </a:r>
+            <a:endParaRPr lang="en-US" sz="1300" dirty="0"/>
+          </a:p>
+        </p:txBody>
+      </p:sp>
+      <p:sp>
+        <p:nvSpPr>
+          <p:cNvPr id="34" name="Text 29"/>
+          <p:cNvSpPr txBox="1"/>
+          <p:nvPr/>
+        </p:nvSpPr>
+        <p:spPr>
+          <a:xfrm>
+            <a:off x="4535424" y="3904488"/>
+            <a:ext cx="3118104" cy="1645920"/>
           </a:xfrm>
           <a:prstGeom prst="rect">
             <a:avLst/>
@@ -2234,42 +2593,26 @@
           <a:lstStyle/>
           <a:p>
             <a:pPr indent="0" marL="0">
-              <a:buNone/>
-            </a:pPr>
-            <a:r>
-              <a:rPr lang="en-US" sz="1000" b="1" spc="100" kern="0" dirty="0">
-                <a:solidFill>
-                  <a:schemeClr val="accent2"/>
-                </a:solidFill>
-              </a:rPr>
-              <a:t>OPTUM POSITIONING</a:t>
-            </a:r>
-            <a:endParaRPr lang="en-US" sz="1000" dirty="0"/>
-          </a:p>
-        </p:txBody>
-      </p:sp>
-      <p:sp>
-        <p:nvSpPr>
-          <p:cNvPr id="22" name="Text 17"/>
-          <p:cNvSpPr txBox="1"/>
-          <p:nvPr/>
-        </p:nvSpPr>
-        <p:spPr>
-          <a:xfrm>
-            <a:off x="4535424" y="3611880"/>
-            <a:ext cx="3118104" cy="1828800"/>
-          </a:xfrm>
-          <a:prstGeom prst="rect">
-            <a:avLst/>
-          </a:prstGeom>
-          <a:noFill/>
-          <a:ln/>
-        </p:spPr>
-        <p:txBody>
-          <a:bodyPr wrap="square" lIns="0" tIns="0" rIns="0" bIns="0" rtlCol="0" anchor="t"/>
-          <a:lstStyle/>
+              <a:spcAft>
+                <a:spcPts val="900"/>
+              </a:spcAft>
+              <a:buNone/>
+            </a:pPr>
+            <a:r>
+              <a:rPr lang="en-US" sz="1100" dirty="0">
+                <a:solidFill>
+                  <a:schemeClr val="tx1"/>
+                </a:solidFill>
+              </a:rPr>
+              <a:t>Optum LS publicly emphasizes linked healthcare data, AI-enabled research tools and scientific expertise.</a:t>
+            </a:r>
+            <a:endParaRPr lang="en-US" sz="1100" dirty="0"/>
+          </a:p>
           <a:p>
             <a:pPr indent="0" marL="0">
+              <a:spcAft>
+                <a:spcPts val="900"/>
+              </a:spcAft>
               <a:buNone/>
             </a:pPr>
             <a:r>
@@ -2278,9 +2621,15 @@
                   <a:schemeClr val="tx1"/>
                 </a:solidFill>
               </a:rPr>
-              <a:t>Optum LS publicly emphasizes linked healthcare data, AI-enabled research tools and scientific expertise. Several competitors prominently market conversational interfaces as the entry point to comparable customer tasks. </a:t>
-            </a:r>
+              <a:t>Several competitors prominently market conversational interfaces as the entry point to comparable customer tasks.</a:t>
+            </a:r>
+            <a:endParaRPr lang="en-US" sz="1100" dirty="0"/>
+          </a:p>
+          <a:p>
             <a:pPr indent="0" marL="0">
+              <a:spcAft>
+                <a:spcPts val="900"/>
+              </a:spcAft>
               <a:buNone/>
             </a:pPr>
             <a:r>
@@ -2297,14 +2646,14 @@
       </p:sp>
       <p:sp>
         <p:nvSpPr>
-          <p:cNvPr id="23" name="strategic implication card"/>
+          <p:cNvPr id="35" name="strategic implication card"/>
           <p:cNvSpPr/>
           <p:nvPr/>
         </p:nvSpPr>
         <p:spPr>
           <a:xfrm>
-            <a:off x="8065008" y="2788920"/>
-            <a:ext cx="3575304" cy="2816352"/>
+            <a:off x="8065008" y="3035808"/>
+            <a:ext cx="3575304" cy="2606040"/>
           </a:xfrm>
           <a:prstGeom prst="rect">
             <a:avLst/>
@@ -2324,14 +2673,14 @@
       </p:sp>
       <p:sp>
         <p:nvSpPr>
-          <p:cNvPr id="24" name="icon circle"/>
+          <p:cNvPr id="36" name="icon circle"/>
           <p:cNvSpPr/>
           <p:nvPr/>
         </p:nvSpPr>
         <p:spPr>
           <a:xfrm>
-            <a:off x="8293608" y="3017520"/>
-            <a:ext cx="420624" cy="420624"/>
+            <a:off x="8293608" y="3236976"/>
+            <a:ext cx="457200" cy="457200"/>
           </a:xfrm>
           <a:prstGeom prst="ellipse">
             <a:avLst/>
@@ -2344,7 +2693,7 @@
       </p:sp>
       <p:pic>
         <p:nvPicPr>
-          <p:cNvPr id="25" name="icon MdOutlineLightbulb" descr="preencoded.png">    </p:cNvPr>
+          <p:cNvPr id="37" name="icon MdOutlineLightbulb" descr="preencoded.png">    </p:cNvPr>
           <p:cNvPicPr>
             <a:picLocks noChangeAspect="1"/>
           </p:cNvPicPr>
@@ -2358,8 +2707,8 @@
         </p:blipFill>
         <p:spPr>
           <a:xfrm>
-            <a:off x="8386145" y="3110057"/>
-            <a:ext cx="235549" cy="235549"/>
+            <a:off x="8394192" y="3337560"/>
+            <a:ext cx="256032" cy="256032"/>
           </a:xfrm>
           <a:prstGeom prst="rect">
             <a:avLst/>
@@ -2368,14 +2717,50 @@
       </p:pic>
       <p:sp>
         <p:nvSpPr>
-          <p:cNvPr id="26" name="label"/>
-          <p:cNvSpPr txBox="1"/>
-          <p:nvPr/>
-        </p:nvSpPr>
-        <p:spPr>
-          <a:xfrm>
-            <a:off x="8842248" y="3127248"/>
-            <a:ext cx="2560320" cy="201168"/>
+          <p:cNvPr id="38" name="card label"/>
+          <p:cNvSpPr txBox="1"/>
+          <p:nvPr/>
+        </p:nvSpPr>
+        <p:spPr>
+          <a:xfrm>
+            <a:off x="8869680" y="3328416"/>
+            <a:ext cx="2660904" cy="274320"/>
+          </a:xfrm>
+          <a:prstGeom prst="rect">
+            <a:avLst/>
+          </a:prstGeom>
+          <a:noFill/>
+          <a:ln/>
+        </p:spPr>
+        <p:txBody>
+          <a:bodyPr wrap="square" lIns="0" tIns="0" rIns="0" bIns="0" rtlCol="0" anchor="ctr"/>
+          <a:lstStyle/>
+          <a:p>
+            <a:pPr indent="0" marL="0">
+              <a:buNone/>
+            </a:pPr>
+            <a:r>
+              <a:rPr lang="en-US" sz="1300" b="1" spc="150" kern="0" dirty="0">
+                <a:solidFill>
+                  <a:schemeClr val="accent2"/>
+                </a:solidFill>
+              </a:rPr>
+              <a:t>STRATEGIC IMPLICATION</a:t>
+            </a:r>
+            <a:endParaRPr lang="en-US" sz="1300" dirty="0"/>
+          </a:p>
+        </p:txBody>
+      </p:sp>
+      <p:sp>
+        <p:nvSpPr>
+          <p:cNvPr id="39" name="Text 33"/>
+          <p:cNvSpPr txBox="1"/>
+          <p:nvPr/>
+        </p:nvSpPr>
+        <p:spPr>
+          <a:xfrm>
+            <a:off x="8293608" y="3904488"/>
+            <a:ext cx="3118104" cy="685800"/>
           </a:xfrm>
           <a:prstGeom prst="rect">
             <a:avLst/>
@@ -2391,27 +2776,27 @@
               <a:buNone/>
             </a:pPr>
             <a:r>
-              <a:rPr lang="en-US" sz="1000" b="1" spc="100" kern="0" dirty="0">
-                <a:solidFill>
-                  <a:schemeClr val="accent2"/>
-                </a:solidFill>
-              </a:rPr>
-              <a:t>STRATEGIC IMPLICATION</a:t>
-            </a:r>
-            <a:endParaRPr lang="en-US" sz="1000" dirty="0"/>
-          </a:p>
-        </p:txBody>
-      </p:sp>
-      <p:sp>
-        <p:nvSpPr>
-          <p:cNvPr id="27" name="Text 21"/>
-          <p:cNvSpPr txBox="1"/>
-          <p:nvPr/>
-        </p:nvSpPr>
-        <p:spPr>
-          <a:xfrm>
-            <a:off x="8293608" y="3611880"/>
-            <a:ext cx="3118104" cy="731520"/>
+              <a:rPr lang="en-US" sz="1100" dirty="0">
+                <a:solidFill>
+                  <a:schemeClr val="tx1"/>
+                </a:solidFill>
+              </a:rPr>
+              <a:t>The competitive significance of conversational AI depends on the customer task, underlying data and reliability of the results.</a:t>
+            </a:r>
+            <a:endParaRPr lang="en-US" sz="1100" dirty="0"/>
+          </a:p>
+        </p:txBody>
+      </p:sp>
+      <p:sp>
+        <p:nvSpPr>
+          <p:cNvPr id="40" name="strategic question"/>
+          <p:cNvSpPr txBox="1"/>
+          <p:nvPr/>
+        </p:nvSpPr>
+        <p:spPr>
+          <a:xfrm>
+            <a:off x="8293608" y="4636008"/>
+            <a:ext cx="3118104" cy="868680"/>
           </a:xfrm>
           <a:prstGeom prst="rect">
             <a:avLst/>
@@ -2427,42 +2812,6 @@
               <a:buNone/>
             </a:pPr>
             <a:r>
-              <a:rPr lang="en-US" sz="1100" dirty="0">
-                <a:solidFill>
-                  <a:schemeClr val="tx1"/>
-                </a:solidFill>
-              </a:rPr>
-              <a:t>The competitive significance of conversational AI depends on the customer task, underlying data and reliability of the results.</a:t>
-            </a:r>
-            <a:endParaRPr lang="en-US" sz="1100" dirty="0"/>
-          </a:p>
-        </p:txBody>
-      </p:sp>
-      <p:sp>
-        <p:nvSpPr>
-          <p:cNvPr id="28" name="strategic question"/>
-          <p:cNvSpPr txBox="1"/>
-          <p:nvPr/>
-        </p:nvSpPr>
-        <p:spPr>
-          <a:xfrm>
-            <a:off x="8293608" y="4416552"/>
-            <a:ext cx="3118104" cy="914400"/>
-          </a:xfrm>
-          <a:prstGeom prst="rect">
-            <a:avLst/>
-          </a:prstGeom>
-          <a:noFill/>
-          <a:ln/>
-        </p:spPr>
-        <p:txBody>
-          <a:bodyPr wrap="square" lIns="0" tIns="0" rIns="0" bIns="0" rtlCol="0" anchor="t"/>
-          <a:lstStyle/>
-          <a:p>
-            <a:pPr indent="0" marL="0">
-              <a:buNone/>
-            </a:pPr>
-            <a:r>
               <a:rPr lang="en-US" sz="1400" b="1" dirty="0">
                 <a:solidFill>
                   <a:schemeClr val="accent1"/>
@@ -2476,13 +2825,13 @@
       </p:sp>
       <p:sp>
         <p:nvSpPr>
-          <p:cNvPr id="29" name="evidence boundary"/>
-          <p:cNvSpPr txBox="1"/>
-          <p:nvPr/>
-        </p:nvSpPr>
-        <p:spPr>
-          <a:xfrm>
-            <a:off x="548640" y="5733288"/>
+          <p:cNvPr id="41" name="evidence boundary"/>
+          <p:cNvSpPr txBox="1"/>
+          <p:nvPr/>
+        </p:nvSpPr>
+        <p:spPr>
+          <a:xfrm>
+            <a:off x="548640" y="5760720"/>
             <a:ext cx="11091672" cy="365760"/>
           </a:xfrm>
           <a:prstGeom prst="rect">
@@ -2664,7 +3013,7 @@
         </p:nvSpPr>
         <p:spPr>
           <a:xfrm>
-            <a:off x="548640" y="1517904"/>
+            <a:off x="548640" y="1463040"/>
             <a:ext cx="5486400" cy="201168"/>
           </a:xfrm>
           <a:prstGeom prst="rect">
@@ -2700,8 +3049,8 @@
         </p:nvSpPr>
         <p:spPr>
           <a:xfrm>
-            <a:off x="548640" y="1783080"/>
-            <a:ext cx="2438400" cy="658368"/>
+            <a:off x="548640" y="1700784"/>
+            <a:ext cx="3319272" cy="530352"/>
           </a:xfrm>
           <a:prstGeom prst="rect">
             <a:avLst/>
@@ -2720,8 +3069,8 @@
         </p:nvSpPr>
         <p:spPr>
           <a:xfrm>
-            <a:off x="685800" y="1783080"/>
-            <a:ext cx="685800" cy="658368"/>
+            <a:off x="713232" y="1700784"/>
+            <a:ext cx="685800" cy="530352"/>
           </a:xfrm>
           <a:prstGeom prst="rect">
             <a:avLst/>
@@ -2737,14 +3086,14 @@
               <a:buNone/>
             </a:pPr>
             <a:r>
-              <a:rPr lang="en-US" sz="2800" b="1" dirty="0">
+              <a:rPr lang="en-US" sz="2600" b="1" dirty="0">
                 <a:solidFill>
                   <a:schemeClr val="bg1"/>
                 </a:solidFill>
               </a:rPr>
               <a:t>45</a:t>
             </a:r>
-            <a:endParaRPr lang="en-US" sz="2800" dirty="0"/>
+            <a:endParaRPr lang="en-US" sz="2600" dirty="0"/>
           </a:p>
         </p:txBody>
       </p:sp>
@@ -2756,8 +3105,8 @@
         </p:nvSpPr>
         <p:spPr>
           <a:xfrm>
-            <a:off x="1389888" y="1783080"/>
-            <a:ext cx="1505712" cy="658368"/>
+            <a:off x="1417320" y="1700784"/>
+            <a:ext cx="2331720" cy="530352"/>
           </a:xfrm>
           <a:prstGeom prst="rect">
             <a:avLst/>
@@ -2773,27 +3122,47 @@
               <a:buNone/>
             </a:pPr>
             <a:r>
-              <a:rPr lang="en-US" sz="950" dirty="0">
+              <a:rPr lang="en-US" sz="1000" dirty="0">
                 <a:solidFill>
                   <a:schemeClr val="bg1"/>
                 </a:solidFill>
               </a:rPr>
               <a:t>competitor groups initially screened</a:t>
             </a:r>
-            <a:endParaRPr lang="en-US" sz="950" dirty="0"/>
-          </a:p>
-        </p:txBody>
-      </p:sp>
-      <p:sp>
-        <p:nvSpPr>
-          <p:cNvPr id="8" name="kpi tile 15"/>
+            <a:endParaRPr lang="en-US" sz="1000" dirty="0"/>
+          </a:p>
+        </p:txBody>
+      </p:sp>
+      <p:sp>
+        <p:nvSpPr>
+          <p:cNvPr id="8" name="flow arrow"/>
           <p:cNvSpPr/>
           <p:nvPr/>
         </p:nvSpPr>
         <p:spPr>
           <a:xfrm>
-            <a:off x="3124200" y="1783080"/>
-            <a:ext cx="2438400" cy="658368"/>
+            <a:off x="3995928" y="1847088"/>
+            <a:ext cx="310896" cy="237744"/>
+          </a:xfrm>
+          <a:prstGeom prst="rightArrow">
+            <a:avLst/>
+          </a:prstGeom>
+          <a:solidFill>
+            <a:schemeClr val="accent4"/>
+          </a:solidFill>
+          <a:ln/>
+        </p:spPr>
+      </p:sp>
+      <p:sp>
+        <p:nvSpPr>
+          <p:cNvPr id="9" name="kpi tile 15"/>
+          <p:cNvSpPr/>
+          <p:nvPr/>
+        </p:nvSpPr>
+        <p:spPr>
+          <a:xfrm>
+            <a:off x="4434840" y="1700784"/>
+            <a:ext cx="3319272" cy="530352"/>
           </a:xfrm>
           <a:prstGeom prst="rect">
             <a:avLst/>
@@ -2806,14 +3175,14 @@
       </p:sp>
       <p:sp>
         <p:nvSpPr>
-          <p:cNvPr id="9" name="Text 7"/>
-          <p:cNvSpPr txBox="1"/>
-          <p:nvPr/>
-        </p:nvSpPr>
-        <p:spPr>
-          <a:xfrm>
-            <a:off x="3261360" y="1783080"/>
-            <a:ext cx="685800" cy="658368"/>
+          <p:cNvPr id="10" name="Text 8"/>
+          <p:cNvSpPr txBox="1"/>
+          <p:nvPr/>
+        </p:nvSpPr>
+        <p:spPr>
+          <a:xfrm>
+            <a:off x="4599432" y="1700784"/>
+            <a:ext cx="685800" cy="530352"/>
           </a:xfrm>
           <a:prstGeom prst="rect">
             <a:avLst/>
@@ -2829,27 +3198,27 @@
               <a:buNone/>
             </a:pPr>
             <a:r>
-              <a:rPr lang="en-US" sz="2800" b="1" dirty="0">
+              <a:rPr lang="en-US" sz="2600" b="1" dirty="0">
                 <a:solidFill>
                   <a:schemeClr val="bg1"/>
                 </a:solidFill>
               </a:rPr>
               <a:t>15</a:t>
             </a:r>
-            <a:endParaRPr lang="en-US" sz="2800" dirty="0"/>
-          </a:p>
-        </p:txBody>
-      </p:sp>
-      <p:sp>
-        <p:nvSpPr>
-          <p:cNvPr id="10" name="Text 8"/>
-          <p:cNvSpPr txBox="1"/>
-          <p:nvPr/>
-        </p:nvSpPr>
-        <p:spPr>
-          <a:xfrm>
-            <a:off x="3965448" y="1783080"/>
-            <a:ext cx="1505712" cy="658368"/>
+            <a:endParaRPr lang="en-US" sz="2600" dirty="0"/>
+          </a:p>
+        </p:txBody>
+      </p:sp>
+      <p:sp>
+        <p:nvSpPr>
+          <p:cNvPr id="11" name="Text 9"/>
+          <p:cNvSpPr txBox="1"/>
+          <p:nvPr/>
+        </p:nvSpPr>
+        <p:spPr>
+          <a:xfrm>
+            <a:off x="5303520" y="1700784"/>
+            <a:ext cx="2331720" cy="530352"/>
           </a:xfrm>
           <a:prstGeom prst="rect">
             <a:avLst/>
@@ -2865,27 +3234,47 @@
               <a:buNone/>
             </a:pPr>
             <a:r>
-              <a:rPr lang="en-US" sz="950" dirty="0">
+              <a:rPr lang="en-US" sz="1000" dirty="0">
                 <a:solidFill>
                   <a:schemeClr val="bg1"/>
                 </a:solidFill>
               </a:rPr>
               <a:t>distinct groups marketing qualifying conversational AI</a:t>
             </a:r>
-            <a:endParaRPr lang="en-US" sz="950" dirty="0"/>
-          </a:p>
-        </p:txBody>
-      </p:sp>
-      <p:sp>
-        <p:nvSpPr>
-          <p:cNvPr id="11" name="kpi tile 19"/>
+            <a:endParaRPr lang="en-US" sz="1000" dirty="0"/>
+          </a:p>
+        </p:txBody>
+      </p:sp>
+      <p:sp>
+        <p:nvSpPr>
+          <p:cNvPr id="12" name="flow arrow"/>
           <p:cNvSpPr/>
           <p:nvPr/>
         </p:nvSpPr>
         <p:spPr>
           <a:xfrm>
-            <a:off x="5699760" y="1783080"/>
-            <a:ext cx="2438400" cy="658368"/>
+            <a:off x="7882128" y="1847088"/>
+            <a:ext cx="310896" cy="237744"/>
+          </a:xfrm>
+          <a:prstGeom prst="rightArrow">
+            <a:avLst/>
+          </a:prstGeom>
+          <a:solidFill>
+            <a:schemeClr val="accent4"/>
+          </a:solidFill>
+          <a:ln/>
+        </p:spPr>
+      </p:sp>
+      <p:sp>
+        <p:nvSpPr>
+          <p:cNvPr id="13" name="kpi tile 19"/>
+          <p:cNvSpPr/>
+          <p:nvPr/>
+        </p:nvSpPr>
+        <p:spPr>
+          <a:xfrm>
+            <a:off x="8321040" y="1700784"/>
+            <a:ext cx="3319272" cy="530352"/>
           </a:xfrm>
           <a:prstGeom prst="rect">
             <a:avLst/>
@@ -2898,14 +3287,14 @@
       </p:sp>
       <p:sp>
         <p:nvSpPr>
-          <p:cNvPr id="12" name="Text 10"/>
-          <p:cNvSpPr txBox="1"/>
-          <p:nvPr/>
-        </p:nvSpPr>
-        <p:spPr>
-          <a:xfrm>
-            <a:off x="5836920" y="1783080"/>
-            <a:ext cx="685800" cy="658368"/>
+          <p:cNvPr id="14" name="Text 12"/>
+          <p:cNvSpPr txBox="1"/>
+          <p:nvPr/>
+        </p:nvSpPr>
+        <p:spPr>
+          <a:xfrm>
+            <a:off x="8485632" y="1700784"/>
+            <a:ext cx="685800" cy="530352"/>
           </a:xfrm>
           <a:prstGeom prst="rect">
             <a:avLst/>
@@ -2921,27 +3310,27 @@
               <a:buNone/>
             </a:pPr>
             <a:r>
-              <a:rPr lang="en-US" sz="2800" b="1" dirty="0">
+              <a:rPr lang="en-US" sz="2600" b="1" dirty="0">
                 <a:solidFill>
                   <a:schemeClr val="accent2"/>
                 </a:solidFill>
               </a:rPr>
               <a:t>19</a:t>
             </a:r>
-            <a:endParaRPr lang="en-US" sz="2800" dirty="0"/>
-          </a:p>
-        </p:txBody>
-      </p:sp>
-      <p:sp>
-        <p:nvSpPr>
-          <p:cNvPr id="13" name="Text 11"/>
-          <p:cNvSpPr txBox="1"/>
-          <p:nvPr/>
-        </p:nvSpPr>
-        <p:spPr>
-          <a:xfrm>
-            <a:off x="6541008" y="1783080"/>
-            <a:ext cx="1505712" cy="658368"/>
+            <a:endParaRPr lang="en-US" sz="2600" dirty="0"/>
+          </a:p>
+        </p:txBody>
+      </p:sp>
+      <p:sp>
+        <p:nvSpPr>
+          <p:cNvPr id="15" name="Text 13"/>
+          <p:cNvSpPr txBox="1"/>
+          <p:nvPr/>
+        </p:nvSpPr>
+        <p:spPr>
+          <a:xfrm>
+            <a:off x="9189720" y="1700784"/>
+            <a:ext cx="2331720" cy="530352"/>
           </a:xfrm>
           <a:prstGeom prst="rect">
             <a:avLst/>
@@ -2957,83 +3346,83 @@
               <a:buNone/>
             </a:pPr>
             <a:r>
-              <a:rPr lang="en-US" sz="950" dirty="0">
+              <a:rPr lang="en-US" sz="1000" dirty="0">
                 <a:solidFill>
                   <a:schemeClr val="bg1"/>
                 </a:solidFill>
               </a:rPr>
-              <a:t>qualifying conversational AI offerings across five of six workflows</a:t>
-            </a:r>
-            <a:endParaRPr lang="en-US" sz="950" dirty="0"/>
-          </a:p>
-        </p:txBody>
-      </p:sp>
-      <p:sp>
-        <p:nvSpPr>
-          <p:cNvPr id="14" name="label"/>
-          <p:cNvSpPr txBox="1"/>
+              <a:t>qualifying conversational AI offerings across five decision workflows</a:t>
+            </a:r>
+            <a:endParaRPr lang="en-US" sz="1000" dirty="0"/>
+          </a:p>
+        </p:txBody>
+      </p:sp>
+      <p:sp>
+        <p:nvSpPr>
+          <p:cNvPr id="16" name="label"/>
+          <p:cNvSpPr txBox="1"/>
+          <p:nvPr/>
+        </p:nvSpPr>
+        <p:spPr>
+          <a:xfrm>
+            <a:off x="548640" y="2377440"/>
+            <a:ext cx="6400800" cy="201168"/>
+          </a:xfrm>
+          <a:prstGeom prst="rect">
+            <a:avLst/>
+          </a:prstGeom>
+          <a:noFill/>
+          <a:ln/>
+        </p:spPr>
+        <p:txBody>
+          <a:bodyPr wrap="square" lIns="0" tIns="0" rIns="0" bIns="0" rtlCol="0" anchor="t"/>
+          <a:lstStyle/>
+          <a:p>
+            <a:pPr indent="0" marL="0">
+              <a:buNone/>
+            </a:pPr>
+            <a:r>
+              <a:rPr lang="en-US" sz="1000" b="1" spc="100" kern="0" dirty="0">
+                <a:solidFill>
+                  <a:schemeClr val="accent2"/>
+                </a:solidFill>
+              </a:rPr>
+              <a:t>COMPETITOR COVERAGE AND OPTUM LS POSITIONING</a:t>
+            </a:r>
+            <a:endParaRPr lang="en-US" sz="1000" dirty="0"/>
+          </a:p>
+        </p:txBody>
+      </p:sp>
+      <p:sp>
+        <p:nvSpPr>
+          <p:cNvPr id="17" name="table header"/>
+          <p:cNvSpPr/>
           <p:nvPr/>
         </p:nvSpPr>
         <p:spPr>
           <a:xfrm>
             <a:off x="548640" y="2615184"/>
-            <a:ext cx="6400800" cy="201168"/>
-          </a:xfrm>
-          <a:prstGeom prst="rect">
-            <a:avLst/>
-          </a:prstGeom>
-          <a:noFill/>
-          <a:ln/>
-        </p:spPr>
-        <p:txBody>
-          <a:bodyPr wrap="square" lIns="0" tIns="0" rIns="0" bIns="0" rtlCol="0" anchor="t"/>
-          <a:lstStyle/>
-          <a:p>
-            <a:pPr indent="0" marL="0">
-              <a:buNone/>
-            </a:pPr>
-            <a:r>
-              <a:rPr lang="en-US" sz="1000" b="1" spc="100" kern="0" dirty="0">
-                <a:solidFill>
-                  <a:schemeClr val="accent2"/>
-                </a:solidFill>
-              </a:rPr>
-              <a:t>COMPETITOR COVERAGE AND OPTUM LS POSITIONING</a:t>
-            </a:r>
-            <a:endParaRPr lang="en-US" sz="1000" dirty="0"/>
-          </a:p>
-        </p:txBody>
-      </p:sp>
-      <p:sp>
-        <p:nvSpPr>
-          <p:cNvPr id="15" name="table header"/>
-          <p:cNvSpPr/>
-          <p:nvPr/>
-        </p:nvSpPr>
-        <p:spPr>
-          <a:xfrm>
-            <a:off x="548640" y="2862072"/>
-            <a:ext cx="7589520" cy="365760"/>
+            <a:ext cx="11091672" cy="438912"/>
           </a:xfrm>
           <a:prstGeom prst="rect">
             <a:avLst/>
           </a:prstGeom>
           <a:solidFill>
-            <a:schemeClr val="accent1"/>
+            <a:schemeClr val="accent5"/>
           </a:solidFill>
           <a:ln/>
         </p:spPr>
       </p:sp>
       <p:sp>
         <p:nvSpPr>
-          <p:cNvPr id="16" name="Text 14"/>
-          <p:cNvSpPr txBox="1"/>
-          <p:nvPr/>
-        </p:nvSpPr>
-        <p:spPr>
-          <a:xfrm>
-            <a:off x="640080" y="2862072"/>
-            <a:ext cx="2834640" cy="365760"/>
+          <p:cNvPr id="18" name="Text 16"/>
+          <p:cNvSpPr txBox="1"/>
+          <p:nvPr/>
+        </p:nvSpPr>
+        <p:spPr>
+          <a:xfrm>
+            <a:off x="1097280" y="2615184"/>
+            <a:ext cx="2240280" cy="438912"/>
           </a:xfrm>
           <a:prstGeom prst="rect">
             <a:avLst/>
@@ -3045,31 +3434,45 @@
           <a:bodyPr wrap="square" lIns="0" tIns="0" rIns="0" bIns="0" rtlCol="0" anchor="ctr"/>
           <a:lstStyle/>
           <a:p>
-            <a:pPr algn="r" indent="0" marL="0">
-              <a:buNone/>
-            </a:pPr>
-            <a:r>
-              <a:rPr lang="en-US" sz="850" b="1" dirty="0">
-                <a:solidFill>
-                  <a:schemeClr val="bg1"/>
-                </a:solidFill>
-              </a:rPr>
-              <a:t>U.S. competitors marketing chat / comparable competitors</a:t>
-            </a:r>
-            <a:endParaRPr lang="en-US" sz="850" dirty="0"/>
-          </a:p>
-        </p:txBody>
-      </p:sp>
-      <p:sp>
-        <p:nvSpPr>
-          <p:cNvPr id="17" name="Text 15"/>
-          <p:cNvSpPr txBox="1"/>
-          <p:nvPr/>
-        </p:nvSpPr>
-        <p:spPr>
-          <a:xfrm>
-            <a:off x="3657600" y="2862072"/>
-            <a:ext cx="1691640" cy="365760"/>
+            <a:pPr algn="ctr" indent="0" marL="0">
+              <a:buNone/>
+            </a:pPr>
+            <a:r>
+              <a:rPr lang="en-US" sz="900" b="1" dirty="0">
+                <a:solidFill>
+                  <a:schemeClr val="accent1"/>
+                </a:solidFill>
+              </a:rPr>
+              <a:t>U.S. competitors marketing chat /</a:t>
+            </a:r>
+            <a:endParaRPr lang="en-US" sz="900" dirty="0"/>
+          </a:p>
+          <a:p>
+            <a:pPr algn="ctr" indent="0" marL="0">
+              <a:buNone/>
+            </a:pPr>
+            <a:r>
+              <a:rPr lang="en-US" sz="900" b="1" dirty="0">
+                <a:solidFill>
+                  <a:schemeClr val="accent1"/>
+                </a:solidFill>
+              </a:rPr>
+              <a:t>comparable competitors</a:t>
+            </a:r>
+            <a:endParaRPr lang="en-US" sz="900" dirty="0"/>
+          </a:p>
+        </p:txBody>
+      </p:sp>
+      <p:sp>
+        <p:nvSpPr>
+          <p:cNvPr id="19" name="Text 17"/>
+          <p:cNvSpPr txBox="1"/>
+          <p:nvPr/>
+        </p:nvSpPr>
+        <p:spPr>
+          <a:xfrm>
+            <a:off x="3474720" y="2615184"/>
+            <a:ext cx="1965960" cy="438912"/>
           </a:xfrm>
           <a:prstGeom prst="rect">
             <a:avLst/>
@@ -3085,27 +3488,27 @@
               <a:buNone/>
             </a:pPr>
             <a:r>
-              <a:rPr lang="en-US" sz="850" b="1" dirty="0">
-                <a:solidFill>
-                  <a:schemeClr val="bg1"/>
+              <a:rPr lang="en-US" sz="900" b="1" dirty="0">
+                <a:solidFill>
+                  <a:schemeClr val="accent1"/>
                 </a:solidFill>
               </a:rPr>
               <a:t>Workflow</a:t>
             </a:r>
-            <a:endParaRPr lang="en-US" sz="850" dirty="0"/>
-          </a:p>
-        </p:txBody>
-      </p:sp>
-      <p:sp>
-        <p:nvSpPr>
-          <p:cNvPr id="18" name="Text 16"/>
-          <p:cNvSpPr txBox="1"/>
-          <p:nvPr/>
-        </p:nvSpPr>
-        <p:spPr>
-          <a:xfrm>
-            <a:off x="5440680" y="2862072"/>
-            <a:ext cx="1828800" cy="365760"/>
+            <a:endParaRPr lang="en-US" sz="900" dirty="0"/>
+          </a:p>
+        </p:txBody>
+      </p:sp>
+      <p:sp>
+        <p:nvSpPr>
+          <p:cNvPr id="20" name="Text 18"/>
+          <p:cNvSpPr txBox="1"/>
+          <p:nvPr/>
+        </p:nvSpPr>
+        <p:spPr>
+          <a:xfrm>
+            <a:off x="5486400" y="2615184"/>
+            <a:ext cx="2880360" cy="438912"/>
           </a:xfrm>
           <a:prstGeom prst="rect">
             <a:avLst/>
@@ -3117,31 +3520,31 @@
           <a:bodyPr wrap="square" lIns="0" tIns="0" rIns="0" bIns="0" rtlCol="0" anchor="ctr"/>
           <a:lstStyle/>
           <a:p>
-            <a:pPr indent="0" marL="0">
-              <a:buNone/>
-            </a:pPr>
-            <a:r>
-              <a:rPr lang="en-US" sz="850" b="1" dirty="0">
-                <a:solidFill>
-                  <a:schemeClr val="bg1"/>
-                </a:solidFill>
-              </a:rPr>
-              <a:t>Optum's publicly marketed offerings</a:t>
-            </a:r>
-            <a:endParaRPr lang="en-US" sz="850" dirty="0"/>
-          </a:p>
-        </p:txBody>
-      </p:sp>
-      <p:sp>
-        <p:nvSpPr>
-          <p:cNvPr id="19" name="Text 17"/>
-          <p:cNvSpPr txBox="1"/>
-          <p:nvPr/>
-        </p:nvSpPr>
-        <p:spPr>
-          <a:xfrm>
-            <a:off x="7315200" y="2862072"/>
-            <a:ext cx="822960" cy="365760"/>
+            <a:pPr algn="ctr" indent="0" marL="0">
+              <a:buNone/>
+            </a:pPr>
+            <a:r>
+              <a:rPr lang="en-US" sz="900" b="1" dirty="0">
+                <a:solidFill>
+                  <a:schemeClr val="accent1"/>
+                </a:solidFill>
+              </a:rPr>
+              <a:t>Representative conversational AI offerings</a:t>
+            </a:r>
+            <a:endParaRPr lang="en-US" sz="900" dirty="0"/>
+          </a:p>
+        </p:txBody>
+      </p:sp>
+      <p:sp>
+        <p:nvSpPr>
+          <p:cNvPr id="21" name="Text 19"/>
+          <p:cNvSpPr txBox="1"/>
+          <p:nvPr/>
+        </p:nvSpPr>
+        <p:spPr>
+          <a:xfrm>
+            <a:off x="8503920" y="2615184"/>
+            <a:ext cx="2103120" cy="438912"/>
           </a:xfrm>
           <a:prstGeom prst="rect">
             <a:avLst/>
@@ -3157,26 +3560,76 @@
               <a:buNone/>
             </a:pPr>
             <a:r>
-              <a:rPr lang="en-US" sz="850" b="1" dirty="0">
-                <a:solidFill>
-                  <a:schemeClr val="bg1"/>
+              <a:rPr lang="en-US" sz="900" b="1" dirty="0">
+                <a:solidFill>
+                  <a:schemeClr val="accent1"/>
+                </a:solidFill>
+              </a:rPr>
+              <a:t>Optum's publicly</a:t>
+            </a:r>
+            <a:endParaRPr lang="en-US" sz="900" dirty="0"/>
+          </a:p>
+          <a:p>
+            <a:pPr algn="ctr" indent="0" marL="0">
+              <a:buNone/>
+            </a:pPr>
+            <a:r>
+              <a:rPr lang="en-US" sz="900" b="1" dirty="0">
+                <a:solidFill>
+                  <a:schemeClr val="accent1"/>
+                </a:solidFill>
+              </a:rPr>
+              <a:t>marketed offerings</a:t>
+            </a:r>
+            <a:endParaRPr lang="en-US" sz="900" dirty="0"/>
+          </a:p>
+        </p:txBody>
+      </p:sp>
+      <p:sp>
+        <p:nvSpPr>
+          <p:cNvPr id="22" name="Text 20"/>
+          <p:cNvSpPr txBox="1"/>
+          <p:nvPr/>
+        </p:nvSpPr>
+        <p:spPr>
+          <a:xfrm>
+            <a:off x="10652760" y="2615184"/>
+            <a:ext cx="987552" cy="438912"/>
+          </a:xfrm>
+          <a:prstGeom prst="rect">
+            <a:avLst/>
+          </a:prstGeom>
+          <a:noFill/>
+          <a:ln/>
+        </p:spPr>
+        <p:txBody>
+          <a:bodyPr wrap="square" lIns="0" tIns="0" rIns="0" bIns="0" rtlCol="0" anchor="ctr"/>
+          <a:lstStyle/>
+          <a:p>
+            <a:pPr algn="ctr" indent="0" marL="0">
+              <a:buNone/>
+            </a:pPr>
+            <a:r>
+              <a:rPr lang="en-US" sz="900" b="1" dirty="0">
+                <a:solidFill>
+                  <a:schemeClr val="accent1"/>
                 </a:solidFill>
               </a:rPr>
               <a:t>Optum public chat claim</a:t>
             </a:r>
-            <a:endParaRPr lang="en-US" sz="850" dirty="0"/>
+            <a:endParaRPr lang="en-US" sz="900" dirty="0"/>
           </a:p>
         </p:txBody>
       </p:sp>
       <p:graphicFrame>
         <p:nvGraphicFramePr>
-          <p:cNvPr id="20" name="competitor coverage chart" descr=""/>
+          <p:cNvPr id="23" name="competitor coverage chart" descr=""/>
           <p:cNvGraphicFramePr/>
           <p:nvPr/>
         </p:nvGraphicFramePr>
         <p:xfrm>
-          <a:off x="1188720" y="3227832"/>
-          <a:ext cx="2377440" cy="2103120"/>
+          <a:off x="1170432" y="3054096"/>
+          <a:ext cx="2212848" cy="2240280"/>
         </p:xfrm>
         <a:graphic xmlns:a="http://schemas.openxmlformats.org/drawingml/2006/main">
           <a:graphicData uri="http://schemas.openxmlformats.org/drawingml/2006/chart">
@@ -3186,14 +3639,14 @@
       </p:graphicFrame>
       <p:sp>
         <p:nvSpPr>
-          <p:cNvPr id="21" name="fraction RWE"/>
-          <p:cNvSpPr txBox="1"/>
-          <p:nvPr/>
-        </p:nvSpPr>
-        <p:spPr>
-          <a:xfrm>
-            <a:off x="548640" y="3227832"/>
-            <a:ext cx="566928" cy="420624"/>
+          <p:cNvPr id="24" name="fraction RWE"/>
+          <p:cNvSpPr txBox="1"/>
+          <p:nvPr/>
+        </p:nvSpPr>
+        <p:spPr>
+          <a:xfrm>
+            <a:off x="566928" y="3054096"/>
+            <a:ext cx="548640" cy="448056"/>
           </a:xfrm>
           <a:prstGeom prst="rect">
             <a:avLst/>
@@ -3233,91 +3686,24 @@
       </p:sp>
       <p:sp>
         <p:nvSpPr>
-          <p:cNvPr id="22" name="Text 19"/>
-          <p:cNvSpPr txBox="1"/>
-          <p:nvPr/>
-        </p:nvSpPr>
-        <p:spPr>
-          <a:xfrm>
-            <a:off x="3703320" y="3227832"/>
-            <a:ext cx="1600200" cy="420624"/>
-          </a:xfrm>
-          <a:prstGeom prst="rect">
-            <a:avLst/>
-          </a:prstGeom>
-          <a:noFill/>
-          <a:ln/>
-        </p:spPr>
-        <p:txBody>
-          <a:bodyPr wrap="square" lIns="0" tIns="0" rIns="0" bIns="0" rtlCol="0" anchor="ctr"/>
-          <a:lstStyle/>
-          <a:p>
-            <a:pPr algn="ctr" indent="0" marL="0">
-              <a:buNone/>
-            </a:pPr>
-            <a:r>
-              <a:rPr lang="en-US" sz="1000" b="1" dirty="0">
-                <a:solidFill>
-                  <a:schemeClr val="accent1"/>
-                </a:solidFill>
-              </a:rPr>
-              <a:t>RWE</a:t>
-            </a:r>
-            <a:endParaRPr lang="en-US" sz="1000" dirty="0"/>
-          </a:p>
-        </p:txBody>
-      </p:sp>
-      <p:sp>
-        <p:nvSpPr>
-          <p:cNvPr id="23" name="Text 20"/>
-          <p:cNvSpPr txBox="1"/>
-          <p:nvPr/>
-        </p:nvSpPr>
-        <p:spPr>
-          <a:xfrm>
-            <a:off x="5440680" y="3227832"/>
-            <a:ext cx="1828800" cy="420624"/>
-          </a:xfrm>
-          <a:prstGeom prst="rect">
-            <a:avLst/>
-          </a:prstGeom>
-          <a:noFill/>
-          <a:ln/>
-        </p:spPr>
-        <p:txBody>
-          <a:bodyPr wrap="square" lIns="0" tIns="0" rIns="0" bIns="0" rtlCol="0" anchor="ctr"/>
-          <a:lstStyle/>
-          <a:p>
-            <a:pPr indent="0" marL="0">
-              <a:buNone/>
-            </a:pPr>
-            <a:r>
-              <a:rPr lang="en-US" sz="900" dirty="0">
-                <a:solidFill>
-                  <a:schemeClr val="tx1"/>
-                </a:solidFill>
-              </a:rPr>
-              <a:t>Analytics on Demand; epidemiology research</a:t>
-            </a:r>
-            <a:endParaRPr lang="en-US" sz="900" dirty="0"/>
-          </a:p>
-        </p:txBody>
-      </p:sp>
-      <p:sp>
-        <p:nvSpPr>
-          <p:cNvPr id="24" name="chat status RWE"/>
+          <p:cNvPr id="25" name="workflow chip RWE"/>
           <p:cNvSpPr/>
           <p:nvPr/>
         </p:nvSpPr>
         <p:spPr>
           <a:xfrm>
-            <a:off x="7644384" y="3355848"/>
-            <a:ext cx="164592" cy="164592"/>
-          </a:xfrm>
-          <a:prstGeom prst="ellipse">
-            <a:avLst/>
-          </a:prstGeom>
-          <a:ln w="15875">
+            <a:off x="3547872" y="3122676"/>
+            <a:ext cx="1819656" cy="310896"/>
+          </a:xfrm>
+          <a:prstGeom prst="roundRect">
+            <a:avLst>
+              <a:gd name="adj" fmla="val 50000"/>
+            </a:avLst>
+          </a:prstGeom>
+          <a:solidFill>
+            <a:schemeClr val="accent5"/>
+          </a:solidFill>
+          <a:ln w="9525">
             <a:solidFill>
               <a:schemeClr val="accent1"/>
             </a:solidFill>
@@ -3327,14 +3713,144 @@
       </p:sp>
       <p:sp>
         <p:nvSpPr>
-          <p:cNvPr id="25" name="Shape 22"/>
+          <p:cNvPr id="26" name="Text 23"/>
+          <p:cNvSpPr txBox="1"/>
+          <p:nvPr/>
+        </p:nvSpPr>
+        <p:spPr>
+          <a:xfrm>
+            <a:off x="3547872" y="3122676"/>
+            <a:ext cx="1819656" cy="310896"/>
+          </a:xfrm>
+          <a:prstGeom prst="rect">
+            <a:avLst/>
+          </a:prstGeom>
+          <a:noFill/>
+          <a:ln/>
+        </p:spPr>
+        <p:txBody>
+          <a:bodyPr wrap="square" lIns="0" tIns="0" rIns="0" bIns="0" rtlCol="0" anchor="ctr"/>
+          <a:lstStyle/>
+          <a:p>
+            <a:pPr algn="ctr" indent="0" marL="0">
+              <a:buNone/>
+            </a:pPr>
+            <a:r>
+              <a:rPr lang="en-US" sz="900" b="1" dirty="0">
+                <a:solidFill>
+                  <a:schemeClr val="accent1"/>
+                </a:solidFill>
+              </a:rPr>
+              <a:t>RWE</a:t>
+            </a:r>
+            <a:endParaRPr lang="en-US" sz="900" dirty="0"/>
+          </a:p>
+        </p:txBody>
+      </p:sp>
+      <p:sp>
+        <p:nvSpPr>
+          <p:cNvPr id="27" name="Text 24"/>
+          <p:cNvSpPr txBox="1"/>
+          <p:nvPr/>
+        </p:nvSpPr>
+        <p:spPr>
+          <a:xfrm>
+            <a:off x="5577840" y="3054096"/>
+            <a:ext cx="2697480" cy="448056"/>
+          </a:xfrm>
+          <a:prstGeom prst="rect">
+            <a:avLst/>
+          </a:prstGeom>
+          <a:noFill/>
+          <a:ln/>
+        </p:spPr>
+        <p:txBody>
+          <a:bodyPr wrap="square" lIns="0" tIns="0" rIns="0" bIns="0" rtlCol="0" anchor="ctr"/>
+          <a:lstStyle/>
+          <a:p>
+            <a:pPr indent="0" marL="0">
+              <a:buNone/>
+            </a:pPr>
+            <a:r>
+              <a:rPr lang="en-US" sz="900" dirty="0">
+                <a:solidFill>
+                  <a:schemeClr val="tx1"/>
+                </a:solidFill>
+              </a:rPr>
+              <a:t>Komodo Marmot and MapAI; Truveta Intelligence; Flatiron Telescope; Tempus Lens</a:t>
+            </a:r>
+            <a:endParaRPr lang="en-US" sz="900" dirty="0"/>
+          </a:p>
+        </p:txBody>
+      </p:sp>
+      <p:sp>
+        <p:nvSpPr>
+          <p:cNvPr id="28" name="Text 25"/>
+          <p:cNvSpPr txBox="1"/>
+          <p:nvPr/>
+        </p:nvSpPr>
+        <p:spPr>
+          <a:xfrm>
+            <a:off x="8595360" y="3054096"/>
+            <a:ext cx="1920240" cy="448056"/>
+          </a:xfrm>
+          <a:prstGeom prst="rect">
+            <a:avLst/>
+          </a:prstGeom>
+          <a:noFill/>
+          <a:ln/>
+        </p:spPr>
+        <p:txBody>
+          <a:bodyPr wrap="square" lIns="0" tIns="0" rIns="0" bIns="0" rtlCol="0" anchor="ctr"/>
+          <a:lstStyle/>
+          <a:p>
+            <a:pPr indent="0" marL="0">
+              <a:buNone/>
+            </a:pPr>
+            <a:r>
+              <a:rPr lang="en-US" sz="900" dirty="0">
+                <a:solidFill>
+                  <a:schemeClr val="tx1"/>
+                </a:solidFill>
+              </a:rPr>
+              <a:t>Analytics on Demand; epidemiology research</a:t>
+            </a:r>
+            <a:endParaRPr lang="en-US" sz="900" dirty="0"/>
+          </a:p>
+        </p:txBody>
+      </p:sp>
+      <p:sp>
+        <p:nvSpPr>
+          <p:cNvPr id="29" name="chat status RWE"/>
           <p:cNvSpPr/>
           <p:nvPr/>
         </p:nvSpPr>
         <p:spPr>
           <a:xfrm>
-            <a:off x="548640" y="3648456"/>
-            <a:ext cx="7589520" cy="0"/>
+            <a:off x="11109960" y="3195828"/>
+            <a:ext cx="164592" cy="164592"/>
+          </a:xfrm>
+          <a:prstGeom prst="ellipse">
+            <a:avLst/>
+          </a:prstGeom>
+          <a:ln w="15875">
+            <a:solidFill>
+              <a:schemeClr val="accent4"/>
+            </a:solidFill>
+            <a:prstDash val="solid"/>
+          </a:ln>
+        </p:spPr>
+      </p:sp>
+      <p:sp>
+        <p:nvSpPr>
+          <p:cNvPr id="30" name="Shape 27"/>
+          <p:cNvSpPr/>
+          <p:nvPr/>
+        </p:nvSpPr>
+        <p:spPr>
+          <a:xfrm>
+            <a:off x="548640" y="3502152"/>
+            <a:ext cx="11091672" cy="0"/>
           </a:xfrm>
           <a:prstGeom prst="line">
             <a:avLst/>
@@ -3350,14 +3866,14 @@
       </p:sp>
       <p:sp>
         <p:nvSpPr>
-          <p:cNvPr id="26" name="fraction Commercial intelligence"/>
-          <p:cNvSpPr txBox="1"/>
-          <p:nvPr/>
-        </p:nvSpPr>
-        <p:spPr>
-          <a:xfrm>
-            <a:off x="1317812" y="3648456"/>
-            <a:ext cx="566928" cy="420624"/>
+          <p:cNvPr id="31" name="fraction Commercial intelligence"/>
+          <p:cNvSpPr txBox="1"/>
+          <p:nvPr/>
+        </p:nvSpPr>
+        <p:spPr>
+          <a:xfrm>
+            <a:off x="1282849" y="3502152"/>
+            <a:ext cx="548640" cy="448056"/>
           </a:xfrm>
           <a:prstGeom prst="rect">
             <a:avLst/>
@@ -3397,91 +3913,24 @@
       </p:sp>
       <p:sp>
         <p:nvSpPr>
-          <p:cNvPr id="27" name="Text 24"/>
-          <p:cNvSpPr txBox="1"/>
-          <p:nvPr/>
-        </p:nvSpPr>
-        <p:spPr>
-          <a:xfrm>
-            <a:off x="3703320" y="3648456"/>
-            <a:ext cx="1600200" cy="420624"/>
-          </a:xfrm>
-          <a:prstGeom prst="rect">
-            <a:avLst/>
-          </a:prstGeom>
-          <a:noFill/>
-          <a:ln/>
-        </p:spPr>
-        <p:txBody>
-          <a:bodyPr wrap="square" lIns="0" tIns="0" rIns="0" bIns="0" rtlCol="0" anchor="ctr"/>
-          <a:lstStyle/>
-          <a:p>
-            <a:pPr algn="ctr" indent="0" marL="0">
-              <a:buNone/>
-            </a:pPr>
-            <a:r>
-              <a:rPr lang="en-US" sz="1000" b="1" dirty="0">
-                <a:solidFill>
-                  <a:schemeClr val="accent1"/>
-                </a:solidFill>
-              </a:rPr>
-              <a:t>Commercial intelligence</a:t>
-            </a:r>
-            <a:endParaRPr lang="en-US" sz="1000" dirty="0"/>
-          </a:p>
-        </p:txBody>
-      </p:sp>
-      <p:sp>
-        <p:nvSpPr>
-          <p:cNvPr id="28" name="Text 25"/>
-          <p:cNvSpPr txBox="1"/>
-          <p:nvPr/>
-        </p:nvSpPr>
-        <p:spPr>
-          <a:xfrm>
-            <a:off x="5440680" y="3648456"/>
-            <a:ext cx="1828800" cy="420624"/>
-          </a:xfrm>
-          <a:prstGeom prst="rect">
-            <a:avLst/>
-          </a:prstGeom>
-          <a:noFill/>
-          <a:ln/>
-        </p:spPr>
-        <p:txBody>
-          <a:bodyPr wrap="square" lIns="0" tIns="0" rIns="0" bIns="0" rtlCol="0" anchor="ctr"/>
-          <a:lstStyle/>
-          <a:p>
-            <a:pPr indent="0" marL="0">
-              <a:buNone/>
-            </a:pPr>
-            <a:r>
-              <a:rPr lang="en-US" sz="900" dirty="0">
-                <a:solidFill>
-                  <a:schemeClr val="tx1"/>
-                </a:solidFill>
-              </a:rPr>
-              <a:t>Market Clarity: portfolio and patient/prescriber analytics</a:t>
-            </a:r>
-            <a:endParaRPr lang="en-US" sz="900" dirty="0"/>
-          </a:p>
-        </p:txBody>
-      </p:sp>
-      <p:sp>
-        <p:nvSpPr>
-          <p:cNvPr id="29" name="chat status Commercial intelligence"/>
+          <p:cNvPr id="32" name="workflow chip Commercial intelligence"/>
           <p:cNvSpPr/>
           <p:nvPr/>
         </p:nvSpPr>
         <p:spPr>
           <a:xfrm>
-            <a:off x="7644384" y="3776472"/>
-            <a:ext cx="164592" cy="164592"/>
-          </a:xfrm>
-          <a:prstGeom prst="ellipse">
-            <a:avLst/>
-          </a:prstGeom>
-          <a:ln w="15875">
+            <a:off x="3547872" y="3570732"/>
+            <a:ext cx="1819656" cy="310896"/>
+          </a:xfrm>
+          <a:prstGeom prst="roundRect">
+            <a:avLst>
+              <a:gd name="adj" fmla="val 50000"/>
+            </a:avLst>
+          </a:prstGeom>
+          <a:solidFill>
+            <a:schemeClr val="accent5"/>
+          </a:solidFill>
+          <a:ln w="9525">
             <a:solidFill>
               <a:schemeClr val="accent1"/>
             </a:solidFill>
@@ -3491,14 +3940,144 @@
       </p:sp>
       <p:sp>
         <p:nvSpPr>
-          <p:cNvPr id="30" name="Shape 27"/>
+          <p:cNvPr id="33" name="Text 30"/>
+          <p:cNvSpPr txBox="1"/>
+          <p:nvPr/>
+        </p:nvSpPr>
+        <p:spPr>
+          <a:xfrm>
+            <a:off x="3547872" y="3570732"/>
+            <a:ext cx="1819656" cy="310896"/>
+          </a:xfrm>
+          <a:prstGeom prst="rect">
+            <a:avLst/>
+          </a:prstGeom>
+          <a:noFill/>
+          <a:ln/>
+        </p:spPr>
+        <p:txBody>
+          <a:bodyPr wrap="square" lIns="0" tIns="0" rIns="0" bIns="0" rtlCol="0" anchor="ctr"/>
+          <a:lstStyle/>
+          <a:p>
+            <a:pPr algn="ctr" indent="0" marL="0">
+              <a:buNone/>
+            </a:pPr>
+            <a:r>
+              <a:rPr lang="en-US" sz="900" b="1" dirty="0">
+                <a:solidFill>
+                  <a:schemeClr val="accent1"/>
+                </a:solidFill>
+              </a:rPr>
+              <a:t>Commercial intelligence</a:t>
+            </a:r>
+            <a:endParaRPr lang="en-US" sz="900" dirty="0"/>
+          </a:p>
+        </p:txBody>
+      </p:sp>
+      <p:sp>
+        <p:nvSpPr>
+          <p:cNvPr id="34" name="Text 31"/>
+          <p:cNvSpPr txBox="1"/>
+          <p:nvPr/>
+        </p:nvSpPr>
+        <p:spPr>
+          <a:xfrm>
+            <a:off x="5577840" y="3502152"/>
+            <a:ext cx="2697480" cy="448056"/>
+          </a:xfrm>
+          <a:prstGeom prst="rect">
+            <a:avLst/>
+          </a:prstGeom>
+          <a:noFill/>
+          <a:ln/>
+        </p:spPr>
+        <p:txBody>
+          <a:bodyPr wrap="square" lIns="0" tIns="0" rIns="0" bIns="0" rtlCol="0" anchor="ctr"/>
+          <a:lstStyle/>
+          <a:p>
+            <a:pPr indent="0" marL="0">
+              <a:buNone/>
+            </a:pPr>
+            <a:r>
+              <a:rPr lang="en-US" sz="900" dirty="0">
+                <a:solidFill>
+                  <a:schemeClr val="tx1"/>
+                </a:solidFill>
+              </a:rPr>
+              <a:t>IQVIA Field Force Agent and GMI Agent; ZS Conversational AI for Commercial; Trinity InsightsEDGE Digital Twins</a:t>
+            </a:r>
+            <a:endParaRPr lang="en-US" sz="900" dirty="0"/>
+          </a:p>
+        </p:txBody>
+      </p:sp>
+      <p:sp>
+        <p:nvSpPr>
+          <p:cNvPr id="35" name="Text 32"/>
+          <p:cNvSpPr txBox="1"/>
+          <p:nvPr/>
+        </p:nvSpPr>
+        <p:spPr>
+          <a:xfrm>
+            <a:off x="8595360" y="3502152"/>
+            <a:ext cx="1920240" cy="448056"/>
+          </a:xfrm>
+          <a:prstGeom prst="rect">
+            <a:avLst/>
+          </a:prstGeom>
+          <a:noFill/>
+          <a:ln/>
+        </p:spPr>
+        <p:txBody>
+          <a:bodyPr wrap="square" lIns="0" tIns="0" rIns="0" bIns="0" rtlCol="0" anchor="ctr"/>
+          <a:lstStyle/>
+          <a:p>
+            <a:pPr indent="0" marL="0">
+              <a:buNone/>
+            </a:pPr>
+            <a:r>
+              <a:rPr lang="en-US" sz="900" dirty="0">
+                <a:solidFill>
+                  <a:schemeClr val="tx1"/>
+                </a:solidFill>
+              </a:rPr>
+              <a:t>Market Clarity: portfolio and patient/prescriber analytics</a:t>
+            </a:r>
+            <a:endParaRPr lang="en-US" sz="900" dirty="0"/>
+          </a:p>
+        </p:txBody>
+      </p:sp>
+      <p:sp>
+        <p:nvSpPr>
+          <p:cNvPr id="36" name="chat status Commercial intelligence"/>
           <p:cNvSpPr/>
           <p:nvPr/>
         </p:nvSpPr>
         <p:spPr>
           <a:xfrm>
-            <a:off x="548640" y="4069080"/>
-            <a:ext cx="7589520" cy="0"/>
+            <a:off x="11109960" y="3643884"/>
+            <a:ext cx="164592" cy="164592"/>
+          </a:xfrm>
+          <a:prstGeom prst="ellipse">
+            <a:avLst/>
+          </a:prstGeom>
+          <a:ln w="15875">
+            <a:solidFill>
+              <a:schemeClr val="accent4"/>
+            </a:solidFill>
+            <a:prstDash val="solid"/>
+          </a:ln>
+        </p:spPr>
+      </p:sp>
+      <p:sp>
+        <p:nvSpPr>
+          <p:cNvPr id="37" name="Shape 34"/>
+          <p:cNvSpPr/>
+          <p:nvPr/>
+        </p:nvSpPr>
+        <p:spPr>
+          <a:xfrm>
+            <a:off x="548640" y="3950208"/>
+            <a:ext cx="11091672" cy="0"/>
           </a:xfrm>
           <a:prstGeom prst="line">
             <a:avLst/>
@@ -3514,14 +4093,14 @@
       </p:sp>
       <p:sp>
         <p:nvSpPr>
-          <p:cNvPr id="31" name="fraction Medical / regulatory research"/>
-          <p:cNvSpPr txBox="1"/>
-          <p:nvPr/>
-        </p:nvSpPr>
-        <p:spPr>
-          <a:xfrm>
-            <a:off x="1667435" y="4069080"/>
-            <a:ext cx="566928" cy="420624"/>
+          <p:cNvPr id="38" name="fraction Medical / regulatory research"/>
+          <p:cNvSpPr txBox="1"/>
+          <p:nvPr/>
+        </p:nvSpPr>
+        <p:spPr>
+          <a:xfrm>
+            <a:off x="1608268" y="3950208"/>
+            <a:ext cx="548640" cy="448056"/>
           </a:xfrm>
           <a:prstGeom prst="rect">
             <a:avLst/>
@@ -3561,91 +4140,24 @@
       </p:sp>
       <p:sp>
         <p:nvSpPr>
-          <p:cNvPr id="32" name="Text 29"/>
-          <p:cNvSpPr txBox="1"/>
-          <p:nvPr/>
-        </p:nvSpPr>
-        <p:spPr>
-          <a:xfrm>
-            <a:off x="3703320" y="4069080"/>
-            <a:ext cx="1600200" cy="420624"/>
-          </a:xfrm>
-          <a:prstGeom prst="rect">
-            <a:avLst/>
-          </a:prstGeom>
-          <a:noFill/>
-          <a:ln/>
-        </p:spPr>
-        <p:txBody>
-          <a:bodyPr wrap="square" lIns="0" tIns="0" rIns="0" bIns="0" rtlCol="0" anchor="ctr"/>
-          <a:lstStyle/>
-          <a:p>
-            <a:pPr algn="ctr" indent="0" marL="0">
-              <a:buNone/>
-            </a:pPr>
-            <a:r>
-              <a:rPr lang="en-US" sz="1000" b="1" dirty="0">
-                <a:solidFill>
-                  <a:schemeClr val="accent1"/>
-                </a:solidFill>
-              </a:rPr>
-              <a:t>Medical / regulatory research</a:t>
-            </a:r>
-            <a:endParaRPr lang="en-US" sz="1000" dirty="0"/>
-          </a:p>
-        </p:txBody>
-      </p:sp>
-      <p:sp>
-        <p:nvSpPr>
-          <p:cNvPr id="33" name="Text 30"/>
-          <p:cNvSpPr txBox="1"/>
-          <p:nvPr/>
-        </p:nvSpPr>
-        <p:spPr>
-          <a:xfrm>
-            <a:off x="5440680" y="4069080"/>
-            <a:ext cx="1828800" cy="420624"/>
-          </a:xfrm>
-          <a:prstGeom prst="rect">
-            <a:avLst/>
-          </a:prstGeom>
-          <a:noFill/>
-          <a:ln/>
-        </p:spPr>
-        <p:txBody>
-          <a:bodyPr wrap="square" lIns="0" tIns="0" rIns="0" bIns="0" rtlCol="0" anchor="ctr"/>
-          <a:lstStyle/>
-          <a:p>
-            <a:pPr indent="0" marL="0">
-              <a:buNone/>
-            </a:pPr>
-            <a:r>
-              <a:rPr lang="en-US" sz="900" dirty="0">
-                <a:solidFill>
-                  <a:schemeClr val="tx1"/>
-                </a:solidFill>
-              </a:rPr>
-              <a:t>Postapproval safety studies; Market Clarity medical affairs insights</a:t>
-            </a:r>
-            <a:endParaRPr lang="en-US" sz="900" dirty="0"/>
-          </a:p>
-        </p:txBody>
-      </p:sp>
-      <p:sp>
-        <p:nvSpPr>
-          <p:cNvPr id="34" name="chat status Medical / regulatory research"/>
+          <p:cNvPr id="39" name="workflow chip Medical / regulatory research"/>
           <p:cNvSpPr/>
           <p:nvPr/>
         </p:nvSpPr>
         <p:spPr>
           <a:xfrm>
-            <a:off x="7644384" y="4197096"/>
-            <a:ext cx="164592" cy="164592"/>
-          </a:xfrm>
-          <a:prstGeom prst="ellipse">
-            <a:avLst/>
-          </a:prstGeom>
-          <a:ln w="15875">
+            <a:off x="3547872" y="4018788"/>
+            <a:ext cx="1819656" cy="310896"/>
+          </a:xfrm>
+          <a:prstGeom prst="roundRect">
+            <a:avLst>
+              <a:gd name="adj" fmla="val 50000"/>
+            </a:avLst>
+          </a:prstGeom>
+          <a:solidFill>
+            <a:schemeClr val="accent5"/>
+          </a:solidFill>
+          <a:ln w="9525">
             <a:solidFill>
               <a:schemeClr val="accent1"/>
             </a:solidFill>
@@ -3655,14 +4167,144 @@
       </p:sp>
       <p:sp>
         <p:nvSpPr>
-          <p:cNvPr id="35" name="Shape 32"/>
+          <p:cNvPr id="40" name="Text 37"/>
+          <p:cNvSpPr txBox="1"/>
+          <p:nvPr/>
+        </p:nvSpPr>
+        <p:spPr>
+          <a:xfrm>
+            <a:off x="3547872" y="4018788"/>
+            <a:ext cx="1819656" cy="310896"/>
+          </a:xfrm>
+          <a:prstGeom prst="rect">
+            <a:avLst/>
+          </a:prstGeom>
+          <a:noFill/>
+          <a:ln/>
+        </p:spPr>
+        <p:txBody>
+          <a:bodyPr wrap="square" lIns="0" tIns="0" rIns="0" bIns="0" rtlCol="0" anchor="ctr"/>
+          <a:lstStyle/>
+          <a:p>
+            <a:pPr algn="ctr" indent="0" marL="0">
+              <a:buNone/>
+            </a:pPr>
+            <a:r>
+              <a:rPr lang="en-US" sz="900" b="1" dirty="0">
+                <a:solidFill>
+                  <a:schemeClr val="accent1"/>
+                </a:solidFill>
+              </a:rPr>
+              <a:t>Medical / regulatory research</a:t>
+            </a:r>
+            <a:endParaRPr lang="en-US" sz="900" dirty="0"/>
+          </a:p>
+        </p:txBody>
+      </p:sp>
+      <p:sp>
+        <p:nvSpPr>
+          <p:cNvPr id="41" name="Text 38"/>
+          <p:cNvSpPr txBox="1"/>
+          <p:nvPr/>
+        </p:nvSpPr>
+        <p:spPr>
+          <a:xfrm>
+            <a:off x="5577840" y="3950208"/>
+            <a:ext cx="2697480" cy="448056"/>
+          </a:xfrm>
+          <a:prstGeom prst="rect">
+            <a:avLst/>
+          </a:prstGeom>
+          <a:noFill/>
+          <a:ln/>
+        </p:spPr>
+        <p:txBody>
+          <a:bodyPr wrap="square" lIns="0" tIns="0" rIns="0" bIns="0" rtlCol="0" anchor="ctr"/>
+          <a:lstStyle/>
+          <a:p>
+            <a:pPr indent="0" marL="0">
+              <a:buNone/>
+            </a:pPr>
+            <a:r>
+              <a:rPr lang="en-US" sz="900" dirty="0">
+                <a:solidFill>
+                  <a:schemeClr val="tx1"/>
+                </a:solidFill>
+              </a:rPr>
+              <a:t>IQVIA Med-R1; ZS Conversational AI for Medical; Veeva Vault AI Chat</a:t>
+            </a:r>
+            <a:endParaRPr lang="en-US" sz="900" dirty="0"/>
+          </a:p>
+        </p:txBody>
+      </p:sp>
+      <p:sp>
+        <p:nvSpPr>
+          <p:cNvPr id="42" name="Text 39"/>
+          <p:cNvSpPr txBox="1"/>
+          <p:nvPr/>
+        </p:nvSpPr>
+        <p:spPr>
+          <a:xfrm>
+            <a:off x="8595360" y="3950208"/>
+            <a:ext cx="1920240" cy="448056"/>
+          </a:xfrm>
+          <a:prstGeom prst="rect">
+            <a:avLst/>
+          </a:prstGeom>
+          <a:noFill/>
+          <a:ln/>
+        </p:spPr>
+        <p:txBody>
+          <a:bodyPr wrap="square" lIns="0" tIns="0" rIns="0" bIns="0" rtlCol="0" anchor="ctr"/>
+          <a:lstStyle/>
+          <a:p>
+            <a:pPr indent="0" marL="0">
+              <a:buNone/>
+            </a:pPr>
+            <a:r>
+              <a:rPr lang="en-US" sz="900" dirty="0">
+                <a:solidFill>
+                  <a:schemeClr val="tx1"/>
+                </a:solidFill>
+              </a:rPr>
+              <a:t>Postapproval safety studies; Market Clarity medical affairs insights</a:t>
+            </a:r>
+            <a:endParaRPr lang="en-US" sz="900" dirty="0"/>
+          </a:p>
+        </p:txBody>
+      </p:sp>
+      <p:sp>
+        <p:nvSpPr>
+          <p:cNvPr id="43" name="chat status Medical / regulatory research"/>
           <p:cNvSpPr/>
           <p:nvPr/>
         </p:nvSpPr>
         <p:spPr>
           <a:xfrm>
-            <a:off x="548640" y="4489704"/>
-            <a:ext cx="7589520" cy="0"/>
+            <a:off x="11109960" y="4091940"/>
+            <a:ext cx="164592" cy="164592"/>
+          </a:xfrm>
+          <a:prstGeom prst="ellipse">
+            <a:avLst/>
+          </a:prstGeom>
+          <a:ln w="15875">
+            <a:solidFill>
+              <a:schemeClr val="accent4"/>
+            </a:solidFill>
+            <a:prstDash val="solid"/>
+          </a:ln>
+        </p:spPr>
+      </p:sp>
+      <p:sp>
+        <p:nvSpPr>
+          <p:cNvPr id="44" name="Shape 41"/>
+          <p:cNvSpPr/>
+          <p:nvPr/>
+        </p:nvSpPr>
+        <p:spPr>
+          <a:xfrm>
+            <a:off x="548640" y="4398264"/>
+            <a:ext cx="11091672" cy="0"/>
           </a:xfrm>
           <a:prstGeom prst="line">
             <a:avLst/>
@@ -3678,14 +4320,14 @@
       </p:sp>
       <p:sp>
         <p:nvSpPr>
-          <p:cNvPr id="36" name="fraction Clinical trials"/>
-          <p:cNvSpPr txBox="1"/>
-          <p:nvPr/>
-        </p:nvSpPr>
-        <p:spPr>
-          <a:xfrm>
-            <a:off x="1177962" y="4489704"/>
-            <a:ext cx="566928" cy="420624"/>
+          <p:cNvPr id="45" name="fraction Clinical trials"/>
+          <p:cNvSpPr txBox="1"/>
+          <p:nvPr/>
+        </p:nvSpPr>
+        <p:spPr>
+          <a:xfrm>
+            <a:off x="1152682" y="4398264"/>
+            <a:ext cx="548640" cy="448056"/>
           </a:xfrm>
           <a:prstGeom prst="rect">
             <a:avLst/>
@@ -3725,91 +4367,24 @@
       </p:sp>
       <p:sp>
         <p:nvSpPr>
-          <p:cNvPr id="37" name="Text 34"/>
-          <p:cNvSpPr txBox="1"/>
-          <p:nvPr/>
-        </p:nvSpPr>
-        <p:spPr>
-          <a:xfrm>
-            <a:off x="3703320" y="4489704"/>
-            <a:ext cx="1600200" cy="420624"/>
-          </a:xfrm>
-          <a:prstGeom prst="rect">
-            <a:avLst/>
-          </a:prstGeom>
-          <a:noFill/>
-          <a:ln/>
-        </p:spPr>
-        <p:txBody>
-          <a:bodyPr wrap="square" lIns="0" tIns="0" rIns="0" bIns="0" rtlCol="0" anchor="ctr"/>
-          <a:lstStyle/>
-          <a:p>
-            <a:pPr algn="ctr" indent="0" marL="0">
-              <a:buNone/>
-            </a:pPr>
-            <a:r>
-              <a:rPr lang="en-US" sz="1000" b="1" dirty="0">
-                <a:solidFill>
-                  <a:schemeClr val="accent1"/>
-                </a:solidFill>
-              </a:rPr>
-              <a:t>Clinical trials</a:t>
-            </a:r>
-            <a:endParaRPr lang="en-US" sz="1000" dirty="0"/>
-          </a:p>
-        </p:txBody>
-      </p:sp>
-      <p:sp>
-        <p:nvSpPr>
-          <p:cNvPr id="38" name="Text 35"/>
-          <p:cNvSpPr txBox="1"/>
-          <p:nvPr/>
-        </p:nvSpPr>
-        <p:spPr>
-          <a:xfrm>
-            <a:off x="5440680" y="4489704"/>
-            <a:ext cx="1828800" cy="420624"/>
-          </a:xfrm>
-          <a:prstGeom prst="rect">
-            <a:avLst/>
-          </a:prstGeom>
-          <a:noFill/>
-          <a:ln/>
-        </p:spPr>
-        <p:txBody>
-          <a:bodyPr wrap="square" lIns="0" tIns="0" rIns="0" bIns="0" rtlCol="0" anchor="ctr"/>
-          <a:lstStyle/>
-          <a:p>
-            <a:pPr indent="0" marL="0">
-              <a:buNone/>
-            </a:pPr>
-            <a:r>
-              <a:rPr lang="en-US" sz="900" dirty="0">
-                <a:solidFill>
-                  <a:schemeClr val="tx1"/>
-                </a:solidFill>
-              </a:rPr>
-              <a:t>Prospector; Digital Research Network; True Source</a:t>
-            </a:r>
-            <a:endParaRPr lang="en-US" sz="900" dirty="0"/>
-          </a:p>
-        </p:txBody>
-      </p:sp>
-      <p:sp>
-        <p:nvSpPr>
-          <p:cNvPr id="39" name="chat status Clinical trials"/>
+          <p:cNvPr id="46" name="workflow chip Clinical trials"/>
           <p:cNvSpPr/>
           <p:nvPr/>
         </p:nvSpPr>
         <p:spPr>
           <a:xfrm>
-            <a:off x="7644384" y="4617720"/>
-            <a:ext cx="164592" cy="164592"/>
-          </a:xfrm>
-          <a:prstGeom prst="ellipse">
-            <a:avLst/>
-          </a:prstGeom>
-          <a:ln w="15875">
+            <a:off x="3547872" y="4466844"/>
+            <a:ext cx="1819656" cy="310896"/>
+          </a:xfrm>
+          <a:prstGeom prst="roundRect">
+            <a:avLst>
+              <a:gd name="adj" fmla="val 50000"/>
+            </a:avLst>
+          </a:prstGeom>
+          <a:solidFill>
+            <a:schemeClr val="accent5"/>
+          </a:solidFill>
+          <a:ln w="9525">
             <a:solidFill>
               <a:schemeClr val="accent1"/>
             </a:solidFill>
@@ -3819,14 +4394,144 @@
       </p:sp>
       <p:sp>
         <p:nvSpPr>
-          <p:cNvPr id="40" name="Shape 37"/>
+          <p:cNvPr id="47" name="Text 44"/>
+          <p:cNvSpPr txBox="1"/>
+          <p:nvPr/>
+        </p:nvSpPr>
+        <p:spPr>
+          <a:xfrm>
+            <a:off x="3547872" y="4466844"/>
+            <a:ext cx="1819656" cy="310896"/>
+          </a:xfrm>
+          <a:prstGeom prst="rect">
+            <a:avLst/>
+          </a:prstGeom>
+          <a:noFill/>
+          <a:ln/>
+        </p:spPr>
+        <p:txBody>
+          <a:bodyPr wrap="square" lIns="0" tIns="0" rIns="0" bIns="0" rtlCol="0" anchor="ctr"/>
+          <a:lstStyle/>
+          <a:p>
+            <a:pPr algn="ctr" indent="0" marL="0">
+              <a:buNone/>
+            </a:pPr>
+            <a:r>
+              <a:rPr lang="en-US" sz="900" b="1" dirty="0">
+                <a:solidFill>
+                  <a:schemeClr val="accent1"/>
+                </a:solidFill>
+              </a:rPr>
+              <a:t>Clinical trials</a:t>
+            </a:r>
+            <a:endParaRPr lang="en-US" sz="900" dirty="0"/>
+          </a:p>
+        </p:txBody>
+      </p:sp>
+      <p:sp>
+        <p:nvSpPr>
+          <p:cNvPr id="48" name="Text 45"/>
+          <p:cNvSpPr txBox="1"/>
+          <p:nvPr/>
+        </p:nvSpPr>
+        <p:spPr>
+          <a:xfrm>
+            <a:off x="5577840" y="4398264"/>
+            <a:ext cx="2697480" cy="448056"/>
+          </a:xfrm>
+          <a:prstGeom prst="rect">
+            <a:avLst/>
+          </a:prstGeom>
+          <a:noFill/>
+          <a:ln/>
+        </p:spPr>
+        <p:txBody>
+          <a:bodyPr wrap="square" lIns="0" tIns="0" rIns="0" bIns="0" rtlCol="0" anchor="ctr"/>
+          <a:lstStyle/>
+          <a:p>
+            <a:pPr indent="0" marL="0">
+              <a:buNone/>
+            </a:pPr>
+            <a:r>
+              <a:rPr lang="en-US" sz="900" dirty="0">
+                <a:solidFill>
+                  <a:schemeClr val="tx1"/>
+                </a:solidFill>
+              </a:rPr>
+              <a:t>TriNetX Terrain AI Assistant</a:t>
+            </a:r>
+            <a:endParaRPr lang="en-US" sz="900" dirty="0"/>
+          </a:p>
+        </p:txBody>
+      </p:sp>
+      <p:sp>
+        <p:nvSpPr>
+          <p:cNvPr id="49" name="Text 46"/>
+          <p:cNvSpPr txBox="1"/>
+          <p:nvPr/>
+        </p:nvSpPr>
+        <p:spPr>
+          <a:xfrm>
+            <a:off x="8595360" y="4398264"/>
+            <a:ext cx="1920240" cy="448056"/>
+          </a:xfrm>
+          <a:prstGeom prst="rect">
+            <a:avLst/>
+          </a:prstGeom>
+          <a:noFill/>
+          <a:ln/>
+        </p:spPr>
+        <p:txBody>
+          <a:bodyPr wrap="square" lIns="0" tIns="0" rIns="0" bIns="0" rtlCol="0" anchor="ctr"/>
+          <a:lstStyle/>
+          <a:p>
+            <a:pPr indent="0" marL="0">
+              <a:buNone/>
+            </a:pPr>
+            <a:r>
+              <a:rPr lang="en-US" sz="900" dirty="0">
+                <a:solidFill>
+                  <a:schemeClr val="tx1"/>
+                </a:solidFill>
+              </a:rPr>
+              <a:t>Prospector; Digital Research Network; True Source</a:t>
+            </a:r>
+            <a:endParaRPr lang="en-US" sz="900" dirty="0"/>
+          </a:p>
+        </p:txBody>
+      </p:sp>
+      <p:sp>
+        <p:nvSpPr>
+          <p:cNvPr id="50" name="chat status Clinical trials"/>
           <p:cNvSpPr/>
           <p:nvPr/>
         </p:nvSpPr>
         <p:spPr>
           <a:xfrm>
-            <a:off x="548640" y="4910328"/>
-            <a:ext cx="7589520" cy="0"/>
+            <a:off x="11109960" y="4539996"/>
+            <a:ext cx="164592" cy="164592"/>
+          </a:xfrm>
+          <a:prstGeom prst="ellipse">
+            <a:avLst/>
+          </a:prstGeom>
+          <a:ln w="15875">
+            <a:solidFill>
+              <a:schemeClr val="accent4"/>
+            </a:solidFill>
+            <a:prstDash val="solid"/>
+          </a:ln>
+        </p:spPr>
+      </p:sp>
+      <p:sp>
+        <p:nvSpPr>
+          <p:cNvPr id="51" name="Shape 48"/>
+          <p:cNvSpPr/>
+          <p:nvPr/>
+        </p:nvSpPr>
+        <p:spPr>
+          <a:xfrm>
+            <a:off x="548640" y="4846320"/>
+            <a:ext cx="11091672" cy="0"/>
           </a:xfrm>
           <a:prstGeom prst="line">
             <a:avLst/>
@@ -3842,14 +4547,14 @@
       </p:sp>
       <p:sp>
         <p:nvSpPr>
-          <p:cNvPr id="41" name="fraction Market access"/>
-          <p:cNvSpPr txBox="1"/>
-          <p:nvPr/>
-        </p:nvSpPr>
-        <p:spPr>
-          <a:xfrm>
-            <a:off x="1247887" y="4910328"/>
-            <a:ext cx="566928" cy="420624"/>
+          <p:cNvPr id="52" name="fraction Market access"/>
+          <p:cNvSpPr txBox="1"/>
+          <p:nvPr/>
+        </p:nvSpPr>
+        <p:spPr>
+          <a:xfrm>
+            <a:off x="1217766" y="4846320"/>
+            <a:ext cx="548640" cy="448056"/>
           </a:xfrm>
           <a:prstGeom prst="rect">
             <a:avLst/>
@@ -3889,91 +4594,24 @@
       </p:sp>
       <p:sp>
         <p:nvSpPr>
-          <p:cNvPr id="42" name="Text 39"/>
-          <p:cNvSpPr txBox="1"/>
-          <p:nvPr/>
-        </p:nvSpPr>
-        <p:spPr>
-          <a:xfrm>
-            <a:off x="3703320" y="4910328"/>
-            <a:ext cx="1600200" cy="420624"/>
-          </a:xfrm>
-          <a:prstGeom prst="rect">
-            <a:avLst/>
-          </a:prstGeom>
-          <a:noFill/>
-          <a:ln/>
-        </p:spPr>
-        <p:txBody>
-          <a:bodyPr wrap="square" lIns="0" tIns="0" rIns="0" bIns="0" rtlCol="0" anchor="ctr"/>
-          <a:lstStyle/>
-          <a:p>
-            <a:pPr algn="ctr" indent="0" marL="0">
-              <a:buNone/>
-            </a:pPr>
-            <a:r>
-              <a:rPr lang="en-US" sz="1000" b="1" dirty="0">
-                <a:solidFill>
-                  <a:schemeClr val="accent1"/>
-                </a:solidFill>
-              </a:rPr>
-              <a:t>Market access</a:t>
-            </a:r>
-            <a:endParaRPr lang="en-US" sz="1000" dirty="0"/>
-          </a:p>
-        </p:txBody>
-      </p:sp>
-      <p:sp>
-        <p:nvSpPr>
-          <p:cNvPr id="43" name="Text 40"/>
-          <p:cNvSpPr txBox="1"/>
-          <p:nvPr/>
-        </p:nvSpPr>
-        <p:spPr>
-          <a:xfrm>
-            <a:off x="5440680" y="4910328"/>
-            <a:ext cx="1828800" cy="420624"/>
-          </a:xfrm>
-          <a:prstGeom prst="rect">
-            <a:avLst/>
-          </a:prstGeom>
-          <a:noFill/>
-          <a:ln/>
-        </p:spPr>
-        <p:txBody>
-          <a:bodyPr wrap="square" lIns="0" tIns="0" rIns="0" bIns="0" rtlCol="0" anchor="ctr"/>
-          <a:lstStyle/>
-          <a:p>
-            <a:pPr indent="0" marL="0">
-              <a:buNone/>
-            </a:pPr>
-            <a:r>
-              <a:rPr lang="en-US" sz="900" dirty="0">
-                <a:solidFill>
-                  <a:schemeClr val="tx1"/>
-                </a:solidFill>
-              </a:rPr>
-              <a:t>HEOR/value evidence; Evidence Engine</a:t>
-            </a:r>
-            <a:endParaRPr lang="en-US" sz="900" dirty="0"/>
-          </a:p>
-        </p:txBody>
-      </p:sp>
-      <p:sp>
-        <p:nvSpPr>
-          <p:cNvPr id="44" name="chat status Market access"/>
+          <p:cNvPr id="53" name="workflow chip Market access"/>
           <p:cNvSpPr/>
           <p:nvPr/>
         </p:nvSpPr>
         <p:spPr>
           <a:xfrm>
-            <a:off x="7644384" y="5038344"/>
-            <a:ext cx="164592" cy="164592"/>
-          </a:xfrm>
-          <a:prstGeom prst="ellipse">
-            <a:avLst/>
-          </a:prstGeom>
-          <a:ln w="15875">
+            <a:off x="3547872" y="4914900"/>
+            <a:ext cx="1819656" cy="310896"/>
+          </a:xfrm>
+          <a:prstGeom prst="roundRect">
+            <a:avLst>
+              <a:gd name="adj" fmla="val 50000"/>
+            </a:avLst>
+          </a:prstGeom>
+          <a:solidFill>
+            <a:schemeClr val="accent5"/>
+          </a:solidFill>
+          <a:ln w="9525">
             <a:solidFill>
               <a:schemeClr val="accent1"/>
             </a:solidFill>
@@ -3983,14 +4621,144 @@
       </p:sp>
       <p:sp>
         <p:nvSpPr>
-          <p:cNvPr id="45" name="Shape 42"/>
+          <p:cNvPr id="54" name="Text 51"/>
+          <p:cNvSpPr txBox="1"/>
+          <p:nvPr/>
+        </p:nvSpPr>
+        <p:spPr>
+          <a:xfrm>
+            <a:off x="3547872" y="4914900"/>
+            <a:ext cx="1819656" cy="310896"/>
+          </a:xfrm>
+          <a:prstGeom prst="rect">
+            <a:avLst/>
+          </a:prstGeom>
+          <a:noFill/>
+          <a:ln/>
+        </p:spPr>
+        <p:txBody>
+          <a:bodyPr wrap="square" lIns="0" tIns="0" rIns="0" bIns="0" rtlCol="0" anchor="ctr"/>
+          <a:lstStyle/>
+          <a:p>
+            <a:pPr algn="ctr" indent="0" marL="0">
+              <a:buNone/>
+            </a:pPr>
+            <a:r>
+              <a:rPr lang="en-US" sz="900" b="1" dirty="0">
+                <a:solidFill>
+                  <a:schemeClr val="accent1"/>
+                </a:solidFill>
+              </a:rPr>
+              <a:t>Market access</a:t>
+            </a:r>
+            <a:endParaRPr lang="en-US" sz="900" dirty="0"/>
+          </a:p>
+        </p:txBody>
+      </p:sp>
+      <p:sp>
+        <p:nvSpPr>
+          <p:cNvPr id="55" name="Text 52"/>
+          <p:cNvSpPr txBox="1"/>
+          <p:nvPr/>
+        </p:nvSpPr>
+        <p:spPr>
+          <a:xfrm>
+            <a:off x="5577840" y="4846320"/>
+            <a:ext cx="2697480" cy="448056"/>
+          </a:xfrm>
+          <a:prstGeom prst="rect">
+            <a:avLst/>
+          </a:prstGeom>
+          <a:noFill/>
+          <a:ln/>
+        </p:spPr>
+        <p:txBody>
+          <a:bodyPr wrap="square" lIns="0" tIns="0" rIns="0" bIns="0" rtlCol="0" anchor="ctr"/>
+          <a:lstStyle/>
+          <a:p>
+            <a:pPr indent="0" marL="0">
+              <a:buNone/>
+            </a:pPr>
+            <a:r>
+              <a:rPr lang="en-US" sz="900" dirty="0">
+                <a:solidFill>
+                  <a:schemeClr val="tx1"/>
+                </a:solidFill>
+              </a:rPr>
+              <a:t>EVERSANA Ask NAVLIN</a:t>
+            </a:r>
+            <a:endParaRPr lang="en-US" sz="900" dirty="0"/>
+          </a:p>
+        </p:txBody>
+      </p:sp>
+      <p:sp>
+        <p:nvSpPr>
+          <p:cNvPr id="56" name="Text 53"/>
+          <p:cNvSpPr txBox="1"/>
+          <p:nvPr/>
+        </p:nvSpPr>
+        <p:spPr>
+          <a:xfrm>
+            <a:off x="8595360" y="4846320"/>
+            <a:ext cx="1920240" cy="448056"/>
+          </a:xfrm>
+          <a:prstGeom prst="rect">
+            <a:avLst/>
+          </a:prstGeom>
+          <a:noFill/>
+          <a:ln/>
+        </p:spPr>
+        <p:txBody>
+          <a:bodyPr wrap="square" lIns="0" tIns="0" rIns="0" bIns="0" rtlCol="0" anchor="ctr"/>
+          <a:lstStyle/>
+          <a:p>
+            <a:pPr indent="0" marL="0">
+              <a:buNone/>
+            </a:pPr>
+            <a:r>
+              <a:rPr lang="en-US" sz="900" dirty="0">
+                <a:solidFill>
+                  <a:schemeClr val="tx1"/>
+                </a:solidFill>
+              </a:rPr>
+              <a:t>HEOR/value evidence; Evidence Engine</a:t>
+            </a:r>
+            <a:endParaRPr lang="en-US" sz="900" dirty="0"/>
+          </a:p>
+        </p:txBody>
+      </p:sp>
+      <p:sp>
+        <p:nvSpPr>
+          <p:cNvPr id="57" name="chat status Market access"/>
           <p:cNvSpPr/>
           <p:nvPr/>
         </p:nvSpPr>
         <p:spPr>
           <a:xfrm>
-            <a:off x="548640" y="5330952"/>
-            <a:ext cx="7589520" cy="0"/>
+            <a:off x="11109960" y="4988052"/>
+            <a:ext cx="164592" cy="164592"/>
+          </a:xfrm>
+          <a:prstGeom prst="ellipse">
+            <a:avLst/>
+          </a:prstGeom>
+          <a:ln w="15875">
+            <a:solidFill>
+              <a:schemeClr val="accent4"/>
+            </a:solidFill>
+            <a:prstDash val="solid"/>
+          </a:ln>
+        </p:spPr>
+      </p:sp>
+      <p:sp>
+        <p:nvSpPr>
+          <p:cNvPr id="58" name="Shape 55"/>
+          <p:cNvSpPr/>
+          <p:nvPr/>
+        </p:nvSpPr>
+        <p:spPr>
+          <a:xfrm>
+            <a:off x="548640" y="5294376"/>
+            <a:ext cx="11091672" cy="0"/>
           </a:xfrm>
           <a:prstGeom prst="line">
             <a:avLst/>
@@ -4006,14 +4774,86 @@
       </p:sp>
       <p:sp>
         <p:nvSpPr>
-          <p:cNvPr id="46" name="representative offerings card"/>
+          <p:cNvPr id="59" name="scope note"/>
+          <p:cNvSpPr txBox="1"/>
+          <p:nvPr/>
+        </p:nvSpPr>
+        <p:spPr>
+          <a:xfrm>
+            <a:off x="548640" y="5358384"/>
+            <a:ext cx="8778240" cy="182880"/>
+          </a:xfrm>
+          <a:prstGeom prst="rect">
+            <a:avLst/>
+          </a:prstGeom>
+          <a:noFill/>
+          <a:ln/>
+        </p:spPr>
+        <p:txBody>
+          <a:bodyPr wrap="square" lIns="0" tIns="0" rIns="0" bIns="0" rtlCol="0" anchor="t"/>
+          <a:lstStyle/>
+          <a:p>
+            <a:pPr indent="0" marL="0">
+              <a:buNone/>
+            </a:pPr>
+            <a:r>
+              <a:rPr lang="en-US" sz="800" b="1" dirty="0">
+                <a:solidFill>
+                  <a:schemeClr val="accent4"/>
+                </a:solidFill>
+              </a:rPr>
+              <a:t>Scope note: Offerings are organized by their primary customer decision workflow; supporting data and analytics capabilities may serve more than one workflow.</a:t>
+            </a:r>
+            <a:endParaRPr lang="en-US" sz="800" dirty="0"/>
+          </a:p>
+        </p:txBody>
+      </p:sp>
+      <p:sp>
+        <p:nvSpPr>
+          <p:cNvPr id="60" name="chat claim legend"/>
+          <p:cNvSpPr txBox="1"/>
+          <p:nvPr/>
+        </p:nvSpPr>
+        <p:spPr>
+          <a:xfrm>
+            <a:off x="9418320" y="5358384"/>
+            <a:ext cx="2221992" cy="182880"/>
+          </a:xfrm>
+          <a:prstGeom prst="rect">
+            <a:avLst/>
+          </a:prstGeom>
+          <a:noFill/>
+          <a:ln/>
+        </p:spPr>
+        <p:txBody>
+          <a:bodyPr wrap="square" lIns="0" tIns="0" rIns="0" bIns="0" rtlCol="0" anchor="t"/>
+          <a:lstStyle/>
+          <a:p>
+            <a:pPr algn="r" indent="0" marL="0">
+              <a:buNone/>
+            </a:pPr>
+            <a:r>
+              <a:rPr lang="en-US" sz="800" i="1" dirty="0">
+                <a:solidFill>
+                  <a:schemeClr val="accent4"/>
+                </a:solidFill>
+              </a:rPr>
+              <a:t>○  Not publicly established in this review</a:t>
+            </a:r>
+            <a:endParaRPr lang="en-US" sz="800" dirty="0"/>
+          </a:p>
+        </p:txBody>
+      </p:sp>
+      <p:sp>
+        <p:nvSpPr>
+          <p:cNvPr id="61" name="key takeaway card"/>
           <p:cNvSpPr/>
           <p:nvPr/>
         </p:nvSpPr>
         <p:spPr>
           <a:xfrm>
-            <a:off x="8366760" y="1517904"/>
-            <a:ext cx="3273552" cy="2377440"/>
+            <a:off x="548640" y="5596128"/>
+            <a:ext cx="11091672" cy="548640"/>
           </a:xfrm>
           <a:prstGeom prst="rect">
             <a:avLst/>
@@ -4033,23 +4873,23 @@
       </p:sp>
       <p:sp>
         <p:nvSpPr>
-          <p:cNvPr id="47" name="label"/>
-          <p:cNvSpPr txBox="1"/>
-          <p:nvPr/>
-        </p:nvSpPr>
-        <p:spPr>
-          <a:xfrm>
-            <a:off x="8549640" y="1664208"/>
-            <a:ext cx="2907792" cy="365760"/>
-          </a:xfrm>
-          <a:prstGeom prst="rect">
-            <a:avLst/>
-          </a:prstGeom>
-          <a:noFill/>
-          <a:ln/>
-        </p:spPr>
-        <p:txBody>
-          <a:bodyPr wrap="square" lIns="0" tIns="0" rIns="0" bIns="0" rtlCol="0" anchor="t"/>
+          <p:cNvPr id="62" name="label"/>
+          <p:cNvSpPr txBox="1"/>
+          <p:nvPr/>
+        </p:nvSpPr>
+        <p:spPr>
+          <a:xfrm>
+            <a:off x="731520" y="5596128"/>
+            <a:ext cx="1554480" cy="548640"/>
+          </a:xfrm>
+          <a:prstGeom prst="rect">
+            <a:avLst/>
+          </a:prstGeom>
+          <a:noFill/>
+          <a:ln/>
+        </p:spPr>
+        <p:txBody>
+          <a:bodyPr wrap="square" lIns="0" tIns="0" rIns="0" bIns="0" rtlCol="0" anchor="ctr"/>
           <a:lstStyle/>
           <a:p>
             <a:pPr indent="0" marL="0">
@@ -4061,7 +4901,7 @@
                   <a:schemeClr val="accent2"/>
                 </a:solidFill>
               </a:rPr>
-              <a:t>REPRESENTATIVE CONVERSATIONAL AI OFFERINGS</a:t>
+              <a:t>KEY TAKEAWAY</a:t>
             </a:r>
             <a:endParaRPr lang="en-US" sz="1000" dirty="0"/>
           </a:p>
@@ -4069,403 +4909,37 @@
       </p:sp>
       <p:sp>
         <p:nvSpPr>
-          <p:cNvPr id="48" name="Text 45"/>
-          <p:cNvSpPr txBox="1"/>
-          <p:nvPr/>
-        </p:nvSpPr>
-        <p:spPr>
-          <a:xfrm>
-            <a:off x="8549640" y="2103120"/>
-            <a:ext cx="2907792" cy="1691640"/>
-          </a:xfrm>
-          <a:prstGeom prst="rect">
-            <a:avLst/>
-          </a:prstGeom>
-          <a:noFill/>
-          <a:ln/>
-        </p:spPr>
-        <p:txBody>
-          <a:bodyPr wrap="square" lIns="0" tIns="0" rIns="0" bIns="0" rtlCol="0" anchor="t"/>
+          <p:cNvPr id="63" name="Text 60"/>
+          <p:cNvSpPr txBox="1"/>
+          <p:nvPr/>
+        </p:nvSpPr>
+        <p:spPr>
+          <a:xfrm>
+            <a:off x="2331720" y="5596128"/>
+            <a:ext cx="9125712" cy="548640"/>
+          </a:xfrm>
+          <a:prstGeom prst="rect">
+            <a:avLst/>
+          </a:prstGeom>
+          <a:noFill/>
+          <a:ln/>
+        </p:spPr>
+        <p:txBody>
+          <a:bodyPr wrap="square" lIns="0" tIns="0" rIns="0" bIns="0" rtlCol="0" anchor="ctr"/>
           <a:lstStyle/>
           <a:p>
             <a:pPr indent="0" marL="0">
-              <a:spcAft>
-                <a:spcPts val="300"/>
-              </a:spcAft>
-              <a:buNone/>
-            </a:pPr>
-            <a:r>
-              <a:rPr lang="en-US" sz="900" b="1" dirty="0">
-                <a:solidFill>
-                  <a:schemeClr val="accent1"/>
-                </a:solidFill>
-              </a:rPr>
-              <a:t>RWE:</a:t>
-            </a:r>
-            <a:pPr indent="0" marL="0">
-              <a:spcAft>
-                <a:spcPts val="300"/>
-              </a:spcAft>
-              <a:buNone/>
-            </a:pPr>
-            <a:r>
-              <a:rPr lang="en-US" sz="900" dirty="0">
+              <a:buNone/>
+            </a:pPr>
+            <a:r>
+              <a:rPr lang="en-US" sz="1050" dirty="0">
                 <a:solidFill>
                   <a:schemeClr val="tx1"/>
                 </a:solidFill>
               </a:rPr>
-              <a:t> Komodo Marmot and MapAI; Truveta Intelligence; Flatiron Telescope; Tempus Lens</a:t>
-            </a:r>
-            <a:endParaRPr lang="en-US" sz="900" dirty="0"/>
-          </a:p>
-          <a:p>
-            <a:pPr indent="0" marL="0">
-              <a:spcAft>
-                <a:spcPts val="300"/>
-              </a:spcAft>
-              <a:buNone/>
-            </a:pPr>
-            <a:r>
-              <a:rPr lang="en-US" sz="900" b="1" dirty="0">
-                <a:solidFill>
-                  <a:schemeClr val="accent1"/>
-                </a:solidFill>
-              </a:rPr>
-              <a:t>Commercial intelligence:</a:t>
-            </a:r>
-            <a:pPr indent="0" marL="0">
-              <a:spcAft>
-                <a:spcPts val="300"/>
-              </a:spcAft>
-              <a:buNone/>
-            </a:pPr>
-            <a:r>
-              <a:rPr lang="en-US" sz="900" dirty="0">
-                <a:solidFill>
-                  <a:schemeClr val="tx1"/>
-                </a:solidFill>
-              </a:rPr>
-              <a:t> IQVIA Field Force Agent and GMI Agent; ZS Conversational AI for Commercial; Trinity InsightsEDGE Digital Twins</a:t>
-            </a:r>
-            <a:endParaRPr lang="en-US" sz="900" dirty="0"/>
-          </a:p>
-          <a:p>
-            <a:pPr indent="0" marL="0">
-              <a:spcAft>
-                <a:spcPts val="300"/>
-              </a:spcAft>
-              <a:buNone/>
-            </a:pPr>
-            <a:r>
-              <a:rPr lang="en-US" sz="900" b="1" dirty="0">
-                <a:solidFill>
-                  <a:schemeClr val="accent1"/>
-                </a:solidFill>
-              </a:rPr>
-              <a:t>Medical / regulatory:</a:t>
-            </a:r>
-            <a:pPr indent="0" marL="0">
-              <a:spcAft>
-                <a:spcPts val="300"/>
-              </a:spcAft>
-              <a:buNone/>
-            </a:pPr>
-            <a:r>
-              <a:rPr lang="en-US" sz="900" dirty="0">
-                <a:solidFill>
-                  <a:schemeClr val="tx1"/>
-                </a:solidFill>
-              </a:rPr>
-              <a:t> IQVIA Med-R1; ZS Conversational AI for Medical; Veeva Vault AI Chat</a:t>
-            </a:r>
-            <a:endParaRPr lang="en-US" sz="900" dirty="0"/>
-          </a:p>
-          <a:p>
-            <a:pPr indent="0" marL="0">
-              <a:spcAft>
-                <a:spcPts val="300"/>
-              </a:spcAft>
-              <a:buNone/>
-            </a:pPr>
-            <a:r>
-              <a:rPr lang="en-US" sz="900" b="1" dirty="0">
-                <a:solidFill>
-                  <a:schemeClr val="accent1"/>
-                </a:solidFill>
-              </a:rPr>
-              <a:t>Clinical trials:</a:t>
-            </a:r>
-            <a:pPr indent="0" marL="0">
-              <a:spcAft>
-                <a:spcPts val="300"/>
-              </a:spcAft>
-              <a:buNone/>
-            </a:pPr>
-            <a:r>
-              <a:rPr lang="en-US" sz="900" dirty="0">
-                <a:solidFill>
-                  <a:schemeClr val="tx1"/>
-                </a:solidFill>
-              </a:rPr>
-              <a:t> TriNetX Terrain AI Assistant</a:t>
-            </a:r>
-            <a:endParaRPr lang="en-US" sz="900" dirty="0"/>
-          </a:p>
-          <a:p>
-            <a:pPr indent="0" marL="0">
-              <a:spcAft>
-                <a:spcPts val="300"/>
-              </a:spcAft>
-              <a:buNone/>
-            </a:pPr>
-            <a:r>
-              <a:rPr lang="en-US" sz="900" b="1" dirty="0">
-                <a:solidFill>
-                  <a:schemeClr val="accent1"/>
-                </a:solidFill>
-              </a:rPr>
-              <a:t>Market access:</a:t>
-            </a:r>
-            <a:pPr indent="0" marL="0">
-              <a:spcAft>
-                <a:spcPts val="300"/>
-              </a:spcAft>
-              <a:buNone/>
-            </a:pPr>
-            <a:r>
-              <a:rPr lang="en-US" sz="900" dirty="0">
-                <a:solidFill>
-                  <a:schemeClr val="tx1"/>
-                </a:solidFill>
-              </a:rPr>
-              <a:t> EVERSANA Ask NAVLIN</a:t>
-            </a:r>
-            <a:endParaRPr lang="en-US" sz="900" dirty="0"/>
-          </a:p>
-        </p:txBody>
-      </p:sp>
-      <p:sp>
-        <p:nvSpPr>
-          <p:cNvPr id="49" name="key takeaway card"/>
-          <p:cNvSpPr/>
-          <p:nvPr/>
-        </p:nvSpPr>
-        <p:spPr>
-          <a:xfrm>
-            <a:off x="8366760" y="4005072"/>
-            <a:ext cx="3273552" cy="1389888"/>
-          </a:xfrm>
-          <a:prstGeom prst="rect">
-            <a:avLst/>
-          </a:prstGeom>
-          <a:solidFill>
-            <a:schemeClr val="bg1"/>
-          </a:solidFill>
-          <a:ln/>
-          <a:effectLst>
-            <a:outerShdw sx="100000" sy="100000" kx="0" ky="0" algn="bl" rotWithShape="0" blurRad="101600" dist="25400" dir="5400000">
-              <a:srgbClr val="000000">
-                <a:alpha val="10000"/>
-              </a:srgbClr>
-            </a:outerShdw>
-          </a:effectLst>
-        </p:spPr>
-      </p:sp>
-      <p:sp>
-        <p:nvSpPr>
-          <p:cNvPr id="50" name="label"/>
-          <p:cNvSpPr txBox="1"/>
-          <p:nvPr/>
-        </p:nvSpPr>
-        <p:spPr>
-          <a:xfrm>
-            <a:off x="8549640" y="4142232"/>
-            <a:ext cx="2907792" cy="201168"/>
-          </a:xfrm>
-          <a:prstGeom prst="rect">
-            <a:avLst/>
-          </a:prstGeom>
-          <a:noFill/>
-          <a:ln/>
-        </p:spPr>
-        <p:txBody>
-          <a:bodyPr wrap="square" lIns="0" tIns="0" rIns="0" bIns="0" rtlCol="0" anchor="t"/>
-          <a:lstStyle/>
-          <a:p>
-            <a:pPr indent="0" marL="0">
-              <a:buNone/>
-            </a:pPr>
-            <a:r>
-              <a:rPr lang="en-US" sz="1000" b="1" spc="100" kern="0" dirty="0">
-                <a:solidFill>
-                  <a:schemeClr val="accent2"/>
-                </a:solidFill>
-              </a:rPr>
-              <a:t>KEY TAKEAWAY</a:t>
-            </a:r>
-            <a:endParaRPr lang="en-US" sz="1000" dirty="0"/>
-          </a:p>
-        </p:txBody>
-      </p:sp>
-      <p:sp>
-        <p:nvSpPr>
-          <p:cNvPr id="51" name="Text 48"/>
-          <p:cNvSpPr txBox="1"/>
-          <p:nvPr/>
-        </p:nvSpPr>
-        <p:spPr>
-          <a:xfrm>
-            <a:off x="8549640" y="4389120"/>
-            <a:ext cx="2907792" cy="914400"/>
-          </a:xfrm>
-          <a:prstGeom prst="rect">
-            <a:avLst/>
-          </a:prstGeom>
-          <a:noFill/>
-          <a:ln/>
-        </p:spPr>
-        <p:txBody>
-          <a:bodyPr wrap="square" lIns="0" tIns="0" rIns="0" bIns="0" rtlCol="0" anchor="t"/>
-          <a:lstStyle/>
-          <a:p>
-            <a:pPr indent="0" marL="0">
-              <a:buNone/>
-            </a:pPr>
-            <a:r>
-              <a:rPr lang="en-US" sz="950" dirty="0">
-                <a:solidFill>
-                  <a:schemeClr val="tx1"/>
-                </a:solidFill>
-              </a:rPr>
               <a:t>RWE has the largest number of screened U.S. companies marketing qualifying conversational AI. Optum offers products and services across the five decision workflows shown, but a qualifying customer-facing conversational interface was not established in the reviewed public materials.</a:t>
             </a:r>
-            <a:endParaRPr lang="en-US" sz="950" dirty="0"/>
-          </a:p>
-        </p:txBody>
-      </p:sp>
-      <p:sp>
-        <p:nvSpPr>
-          <p:cNvPr id="52" name="scope and methodology notes"/>
-          <p:cNvSpPr txBox="1"/>
-          <p:nvPr/>
-        </p:nvSpPr>
-        <p:spPr>
-          <a:xfrm>
-            <a:off x="548640" y="5458968"/>
-            <a:ext cx="11091672" cy="685800"/>
-          </a:xfrm>
-          <a:prstGeom prst="rect">
-            <a:avLst/>
-          </a:prstGeom>
-          <a:noFill/>
-          <a:ln/>
-        </p:spPr>
-        <p:txBody>
-          <a:bodyPr wrap="square" lIns="0" tIns="0" rIns="0" bIns="0" rtlCol="0" anchor="t"/>
-          <a:lstStyle/>
-          <a:p>
-            <a:pPr indent="0" marL="0">
-              <a:spcAft>
-                <a:spcPts val="200"/>
-              </a:spcAft>
-              <a:buNone/>
-            </a:pPr>
-            <a:r>
-              <a:rPr lang="en-US" sz="800" b="1" dirty="0">
-                <a:solidFill>
-                  <a:schemeClr val="accent4"/>
-                </a:solidFill>
-              </a:rPr>
-              <a:t>Scope note: Data access/enrichment is a cross-workflow enabling category. Zero qualifying chat offerings assigned primarily to this domain does not imply an absence of conversational data-access capabilities in products classified under RWE or other workflows.</a:t>
-            </a:r>
-            <a:endParaRPr lang="en-US" sz="800" dirty="0"/>
-          </a:p>
-          <a:p>
-            <a:pPr indent="0" marL="0">
-              <a:spcAft>
-                <a:spcPts val="200"/>
-              </a:spcAft>
-              <a:buNone/>
-            </a:pPr>
-            <a:r>
-              <a:rPr lang="en-US" sz="800" b="1" dirty="0">
-                <a:solidFill>
-                  <a:schemeClr val="accent4"/>
-                </a:solidFill>
-              </a:rPr>
-              <a:t>METHODOLOGY NOTE  </a:t>
-            </a:r>
-            <a:pPr indent="0" marL="0">
-              <a:spcAft>
-                <a:spcPts val="200"/>
-              </a:spcAft>
-              <a:buNone/>
-            </a:pPr>
-            <a:r>
-              <a:rPr lang="en-US" sz="800" dirty="0">
-                <a:solidFill>
-                  <a:schemeClr val="accent4"/>
-                </a:solidFill>
-              </a:rPr>
-              <a:t>Comparable competitors include </a:t>
-            </a:r>
-            <a:pPr indent="0" marL="0">
-              <a:spcAft>
-                <a:spcPts val="200"/>
-              </a:spcAft>
-              <a:buNone/>
-            </a:pPr>
-            <a:r>
-              <a:rPr lang="en-US" sz="800" b="1" dirty="0">
-                <a:solidFill>
-                  <a:schemeClr val="accent4"/>
-                </a:solidFill>
-              </a:rPr>
-              <a:t>direct and specialized/partial offering-level competitors</a:t>
-            </a:r>
-            <a:pPr indent="0" marL="0">
-              <a:spcAft>
-                <a:spcPts val="200"/>
-              </a:spcAft>
-              <a:buNone/>
-            </a:pPr>
-            <a:r>
-              <a:rPr lang="en-US" sz="800" dirty="0">
-                <a:solidFill>
-                  <a:schemeClr val="accent4"/>
-                </a:solidFill>
-              </a:rPr>
-              <a:t> serving similar customer tasks; adjacent participants are excluded. Counts represent distinct company groups per workflow, not product totals. A company may appear in multiple workflows. Optum's ○ indicates that a qualifying conversational interface was </a:t>
-            </a:r>
-            <a:pPr indent="0" marL="0">
-              <a:spcAft>
-                <a:spcPts val="200"/>
-              </a:spcAft>
-              <a:buNone/>
-            </a:pPr>
-            <a:r>
-              <a:rPr lang="en-US" sz="800" i="1" dirty="0">
-                <a:solidFill>
-                  <a:schemeClr val="accent4"/>
-                </a:solidFill>
-              </a:rPr>
-              <a:t>not publicly established in this review</a:t>
-            </a:r>
-            <a:pPr indent="0" marL="0">
-              <a:spcAft>
-                <a:spcPts val="200"/>
-              </a:spcAft>
-              <a:buNone/>
-            </a:pPr>
-            <a:r>
-              <a:rPr lang="en-US" sz="800" dirty="0">
-                <a:solidFill>
-                  <a:schemeClr val="accent4"/>
-                </a:solidFill>
-              </a:rPr>
-              <a:t>, not that the capability is absent. These are selected screened companies, not market-wide adoption rates.</a:t>
-            </a:r>
-            <a:endParaRPr lang="en-US" sz="800" dirty="0"/>
+            <a:endParaRPr lang="en-US" sz="1050" dirty="0"/>
           </a:p>
         </p:txBody>
       </p:sp>

</xml_diff>